<commit_message>
Rebuild presentation: notebook markdown as source of truth, corrected metrics (72.4%/0.798), added Summary of Key Insights slide
</commit_message>
<xml_diff>
--- a/Predicting_Contraceptive_Use_Presentation_Updated.pptx
+++ b/Predicting_Contraceptive_Use_Presentation_Updated.pptx
@@ -32,6 +32,8 @@
     <p:sldId id="280" r:id="rId31"/>
     <p:sldId id="281" r:id="rId32"/>
     <p:sldId id="282" r:id="rId33"/>
+    <p:sldId id="283" r:id="rId34"/>
+    <p:sldId id="284" r:id="rId35"/>
   </p:sldIdLst>
   <p:sldSz cx="12191695" cy="6858000" type="screen4x3"/>
   <p:notesSz cx="6858000" cy="9144000"/>
@@ -3656,7 +3658,7 @@
               </a:defRPr>
             </a:pPr>
             <a:r>
-              <a:t>Moringa School Capstone  •  The Insight Architects  •  10 / 24</a:t>
+              <a:t>Moringa School Capstone  •  The Insight Architects  •  10 / 28</a:t>
             </a:r>
           </a:p>
         </p:txBody>
@@ -3753,7 +3755,7 @@
               </a:defRPr>
             </a:pPr>
             <a:r>
-              <a:t>Massive County Variation</a:t>
+              <a:t>Massive County-Level Variation</a:t>
             </a:r>
           </a:p>
           <a:p>
@@ -3775,7 +3777,7 @@
               </a:defRPr>
             </a:pPr>
             <a:r>
-              <a:t>Lowest: Mandera (1.2%), Wajir (2.8%), Garissa (4.5%), Marsabit (5.6%)</a:t>
+              <a:t>Lowest: Mandera (1.2%), Wajir (2.8%), Garissa (4.5%), Marsabit (5.6%), Tana River (20.0%)</a:t>
             </a:r>
           </a:p>
           <a:p>
@@ -3863,7 +3865,7 @@
               </a:defRPr>
             </a:pPr>
             <a:r>
-              <a:t>Geographically targeted interventions are essential — national averages mislead.</a:t>
+              <a:t>County is the single strongest signal in the data. Geographically targeted interventions are essential.</a:t>
             </a:r>
           </a:p>
         </p:txBody>
@@ -4206,7 +4208,7 @@
               </a:defRPr>
             </a:pPr>
             <a:r>
-              <a:t>Moringa School Capstone  •  The Insight Architects  •  11 / 24</a:t>
+              <a:t>Moringa School Capstone  •  The Insight Architects  •  11 / 28</a:t>
             </a:r>
           </a:p>
         </p:txBody>
@@ -4325,7 +4327,7 @@
               </a:defRPr>
             </a:pPr>
             <a:r>
-              <a:t>No education + any wealth: 9–21% modern use.</a:t>
+              <a:t>No education + any wealth: modern use stays 9–21%.</a:t>
             </a:r>
           </a:p>
           <a:p>
@@ -4347,7 +4349,7 @@
               </a:defRPr>
             </a:pPr>
             <a:r>
-              <a:t>Any education + poorest: still ~35–48%.</a:t>
+              <a:t>Any education + even Poorest household: 35–48%.</a:t>
             </a:r>
           </a:p>
           <a:p>
@@ -4391,29 +4393,7 @@
               </a:defRPr>
             </a:pPr>
             <a:r>
-              <a:t>Literacy and health education are far more critical than income for long-term family planning adoption.</a:t>
-            </a:r>
-          </a:p>
-          <a:p>
-            <a:pPr>
-              <a:lnSpc>
-                <a:spcPct val="115000"/>
-              </a:lnSpc>
-              <a:spcBef>
-                <a:spcPts val="200"/>
-              </a:spcBef>
-              <a:spcAft>
-                <a:spcPts val="400"/>
-              </a:spcAft>
-              <a:defRPr sz="1100" b="0" i="0">
-                <a:solidFill>
-                  <a:srgbClr val="334155"/>
-                </a:solidFill>
-                <a:latin typeface="Segoe UI"/>
-              </a:defRPr>
-            </a:pPr>
-            <a:r>
-              <a:t>Wealth cannot compensate for lack of education.</a:t>
+              <a:t>Education outweighs wealth. No-education women have low use regardless of wealth quintile, while any education pushes it up across every wealth group.</a:t>
             </a:r>
           </a:p>
         </p:txBody>
@@ -4756,7 +4736,7 @@
               </a:defRPr>
             </a:pPr>
             <a:r>
-              <a:t>Moringa School Capstone  •  The Insight Architects  •  12 / 24</a:t>
+              <a:t>Moringa School Capstone  •  The Insight Architects  •  12 / 28</a:t>
             </a:r>
           </a:p>
         </p:txBody>
@@ -4897,7 +4877,7 @@
               </a:defRPr>
             </a:pPr>
             <a:r>
-              <a:t>Resolved by deriving child_loss and surviving_ratio.</a:t>
+              <a:t>Keeping both creates multicollinearity — we derive surviving_ratio and child_loss instead.</a:t>
             </a:r>
           </a:p>
           <a:p>
@@ -5507,7 +5487,7 @@
               </a:defRPr>
             </a:pPr>
             <a:r>
-              <a:t>Moringa School Capstone  •  The Insight Architects  •  14 / 24</a:t>
+              <a:t>Moringa School Capstone  •  The Insight Architects  •  14 / 28</a:t>
             </a:r>
           </a:p>
         </p:txBody>
@@ -5626,7 +5606,7 @@
               </a:defRPr>
             </a:pPr>
             <a:r>
-              <a:t>age_first_birth: 8,813 missing — all women with 0 children.</a:t>
+              <a:t>age_first_birth: 8,813 missing — all women with 0 children (structural, not error).</a:t>
             </a:r>
           </a:p>
           <a:p>
@@ -5648,7 +5628,7 @@
               </a:defRPr>
             </a:pPr>
             <a:r>
-              <a:t>partner_education: 14,039 missing — women with no partner.</a:t>
+              <a:t>partner_education: ~14,000 missing — women with no current partner.</a:t>
             </a:r>
           </a:p>
           <a:p>
@@ -5670,7 +5650,7 @@
               </a:defRPr>
             </a:pPr>
             <a:r>
-              <a:t>Imputed 0 for age_first_birth for nulliparous women</a:t>
+              <a:t>Imputed 0 for age_first_birth; created has_given_birth flag</a:t>
             </a:r>
           </a:p>
           <a:p>
@@ -5692,7 +5672,7 @@
               </a:defRPr>
             </a:pPr>
             <a:r>
-              <a:t>Created has_given_birth binary flag</a:t>
+              <a:t>Filled partner_education with 'No partner' as valid 6th category</a:t>
             </a:r>
           </a:p>
           <a:p>
@@ -5736,7 +5716,7 @@
               </a:defRPr>
             </a:pPr>
             <a:r>
-              <a:t>274 rows flagged. All 532 look-alikes have unique caseids.</a:t>
+              <a:t>274 rows flagged. All 532 look-alikes have unique caseids — distinct women.</a:t>
             </a:r>
           </a:p>
           <a:p>
@@ -5758,7 +5738,7 @@
               </a:defRPr>
             </a:pPr>
             <a:r>
-              <a:t>All 32,156 rows retained for statistical integrity.</a:t>
+              <a:t>All 32,156 rows deliberately retained.</a:t>
             </a:r>
           </a:p>
         </p:txBody>
@@ -5907,7 +5887,7 @@
               </a:defRPr>
             </a:pPr>
             <a:r>
-              <a:t>Before &amp; After Summary</a:t>
+              <a:t>Before &amp; After</a:t>
             </a:r>
           </a:p>
           <a:p>
@@ -5995,7 +5975,7 @@
               </a:defRPr>
             </a:pPr>
             <a:r>
-              <a:t>Every downstream step inherits guaranteed completeness.</a:t>
+              <a:t>Every downstream step inherits guaranteed data completeness.</a:t>
             </a:r>
           </a:p>
         </p:txBody>
@@ -6262,7 +6242,7 @@
               </a:defRPr>
             </a:pPr>
             <a:r>
-              <a:t>Moringa School Capstone  •  The Insight Architects  •  15 / 24</a:t>
+              <a:t>Moringa School Capstone  •  The Insight Architects  •  15 / 28</a:t>
             </a:r>
           </a:p>
         </p:txBody>
@@ -6381,7 +6361,7 @@
               </a:defRPr>
             </a:pPr>
             <a:r>
-              <a:t>education, wealth, age_group encoded ordinally for tree models.</a:t>
+              <a:t>education, wealth, partner_education, age_group encoded ordinally.</a:t>
             </a:r>
           </a:p>
           <a:p>
@@ -6447,7 +6427,7 @@
               </a:defRPr>
             </a:pPr>
             <a:r>
-              <a:t>Feature space: 20 raw → 38 engineered → 127 model-ready (post OHE).</a:t>
+              <a:t>Feature space: 20 raw → 38 engineered → 126 model-ready (post OHE).</a:t>
             </a:r>
           </a:p>
           <a:p>
@@ -6491,7 +6471,7 @@
               </a:defRPr>
             </a:pPr>
             <a:r>
-              <a:t>Derived child_loss, surviving_ratio from r=0.98 collinear pair.</a:t>
+              <a:t>Derived child_loss, surviving_ratio from the r=0.98 collinear pair.</a:t>
             </a:r>
           </a:p>
         </p:txBody>
@@ -6632,7 +6612,7 @@
               </a:defRPr>
             </a:pPr>
             <a:r>
-              <a:t>education_gap — partner's minus woman's education</a:t>
+              <a:t>education_gap — partner’s minus woman’s education</a:t>
             </a:r>
           </a:p>
           <a:p>
@@ -6676,7 +6656,7 @@
               </a:defRPr>
             </a:pPr>
             <a:r>
-              <a:t>arid_county — binary flag for ASAL regions</a:t>
+              <a:t>arid_county — binary flag for 9 ASAL counties</a:t>
             </a:r>
           </a:p>
           <a:p>
@@ -6742,7 +6722,7 @@
               </a:defRPr>
             </a:pPr>
             <a:r>
-              <a:t>age_at_first_birth_gap — years since first birth</a:t>
+              <a:t>surviving_ratio — living / born (avoids r=0.98 collinearity)</a:t>
             </a:r>
           </a:p>
           <a:p>
@@ -6764,7 +6744,7 @@
               </a:defRPr>
             </a:pPr>
             <a:r>
-              <a:t>All features motivated by EDA findings.</a:t>
+              <a:t>All features traceable to specific EDA findings.</a:t>
             </a:r>
           </a:p>
         </p:txBody>
@@ -7210,7 +7190,7 @@
               </a:defRPr>
             </a:pPr>
             <a:r>
-              <a:t>Moringa School Capstone  •  The Insight Architects  •  17 / 24</a:t>
+              <a:t>Moringa School Capstone  •  The Insight Architects  •  17 / 28</a:t>
             </a:r>
           </a:p>
         </p:txBody>
@@ -7329,7 +7309,7 @@
               </a:defRPr>
             </a:pPr>
             <a:r>
-              <a:t>Stratified 80/20 split. SMOTE on training data only, upsampling minority classes to 14,955 each.</a:t>
+              <a:t>Stratified 80/20 split. SMOTE on training data only, upsampling to 14,955 each.</a:t>
             </a:r>
           </a:p>
           <a:p>
@@ -7373,29 +7353,7 @@
               </a:defRPr>
             </a:pPr>
             <a:r>
-              <a:t>LightGBM selected for deployment: best accuracy (95.8%) and Macro-AUC (0.951).</a:t>
-            </a:r>
-          </a:p>
-          <a:p>
-            <a:pPr>
-              <a:lnSpc>
-                <a:spcPct val="110000"/>
-              </a:lnSpc>
-              <a:spcBef>
-                <a:spcPts val="800"/>
-              </a:spcBef>
-              <a:spcAft>
-                <a:spcPts val="300"/>
-              </a:spcAft>
-              <a:defRPr sz="1400" b="1" i="0">
-                <a:solidFill>
-                  <a:srgbClr val="0D9488"/>
-                </a:solidFill>
-                <a:latin typeface="Segoe UI"/>
-              </a:defRPr>
-            </a:pPr>
-            <a:r>
-              <a:t>Notable Finding</a:t>
+              <a:t>LightGBM: best accuracy (72.4%) and Macro-AUC (0.798).</a:t>
             </a:r>
           </a:p>
           <a:p>
@@ -7417,7 +7375,7 @@
               </a:defRPr>
             </a:pPr>
             <a:r>
-              <a:t>TabTransformer achieved highest Traditional-class recall (37%), capturing region×religion interactions.</a:t>
+              <a:t>RF has best Macro-F1 (0.390) — a tradeoff worth noting for minority classes.</a:t>
             </a:r>
           </a:p>
         </p:txBody>
@@ -7493,10 +7451,12 @@
                 <a:tableStyleId>{5C22544A-7EE6-4342-B048-85BDC9FD1C3A}</a:tableStyleId>
               </a:tblPr>
               <a:tblGrid>
-                <a:gridCol w="1415719"/>
-                <a:gridCol w="1415719"/>
-                <a:gridCol w="1415719"/>
-                <a:gridCol w="1415722"/>
+                <a:gridCol w="943813"/>
+                <a:gridCol w="943813"/>
+                <a:gridCol w="943813"/>
+                <a:gridCol w="943813"/>
+                <a:gridCol w="943813"/>
+                <a:gridCol w="943814"/>
               </a:tblGrid>
               <a:tr h="384048">
                 <a:tc>
@@ -7595,6 +7555,54 @@
                     </a:solidFill>
                   </a:tcPr>
                 </a:tc>
+                <a:tc>
+                  <a:txBody>
+                    <a:bodyPr/>
+                    <a:lstStyle/>
+                    <a:p>
+                      <a:pPr algn="ctr">
+                        <a:defRPr sz="1100" b="1">
+                          <a:solidFill>
+                            <a:srgbClr val="FFFFFF"/>
+                          </a:solidFill>
+                          <a:latin typeface="Segoe UI"/>
+                        </a:defRPr>
+                      </a:pPr>
+                      <a:r>
+                        <a:t>Modern Recall</a:t>
+                      </a:r>
+                    </a:p>
+                  </a:txBody>
+                  <a:tcPr>
+                    <a:solidFill>
+                      <a:srgbClr val="0D9488"/>
+                    </a:solidFill>
+                  </a:tcPr>
+                </a:tc>
+                <a:tc>
+                  <a:txBody>
+                    <a:bodyPr/>
+                    <a:lstStyle/>
+                    <a:p>
+                      <a:pPr algn="ctr">
+                        <a:defRPr sz="1100" b="1">
+                          <a:solidFill>
+                            <a:srgbClr val="FFFFFF"/>
+                          </a:solidFill>
+                          <a:latin typeface="Segoe UI"/>
+                        </a:defRPr>
+                      </a:pPr>
+                      <a:r>
+                        <a:t>Trad. Recall</a:t>
+                      </a:r>
+                    </a:p>
+                  </a:txBody>
+                  <a:tcPr>
+                    <a:solidFill>
+                      <a:srgbClr val="0D9488"/>
+                    </a:solidFill>
+                  </a:tcPr>
+                </a:tc>
               </a:tr>
               <a:tr h="384048">
                 <a:tc>
@@ -7635,7 +7643,7 @@
                         </a:defRPr>
                       </a:pPr>
                       <a:r>
-                        <a:t>95.8%</a:t>
+                        <a:t>72.4%</a:t>
                       </a:r>
                     </a:p>
                   </a:txBody>
@@ -7659,7 +7667,7 @@
                         </a:defRPr>
                       </a:pPr>
                       <a:r>
-                        <a:t>0.513</a:t>
+                        <a:t>0.367</a:t>
                       </a:r>
                     </a:p>
                   </a:txBody>
@@ -7683,7 +7691,55 @@
                         </a:defRPr>
                       </a:pPr>
                       <a:r>
-                        <a:t>0.951</a:t>
+                        <a:t>0.798</a:t>
+                      </a:r>
+                    </a:p>
+                  </a:txBody>
+                  <a:tcPr>
+                    <a:solidFill>
+                      <a:srgbClr val="FFFFFF"/>
+                    </a:solidFill>
+                  </a:tcPr>
+                </a:tc>
+                <a:tc>
+                  <a:txBody>
+                    <a:bodyPr/>
+                    <a:lstStyle/>
+                    <a:p>
+                      <a:pPr algn="ctr">
+                        <a:defRPr sz="1000" b="1">
+                          <a:solidFill>
+                            <a:srgbClr val="0F172A"/>
+                          </a:solidFill>
+                          <a:latin typeface="Segoe UI"/>
+                        </a:defRPr>
+                      </a:pPr>
+                      <a:r>
+                        <a:t>71%</a:t>
+                      </a:r>
+                    </a:p>
+                  </a:txBody>
+                  <a:tcPr>
+                    <a:solidFill>
+                      <a:srgbClr val="FFFFFF"/>
+                    </a:solidFill>
+                  </a:tcPr>
+                </a:tc>
+                <a:tc>
+                  <a:txBody>
+                    <a:bodyPr/>
+                    <a:lstStyle/>
+                    <a:p>
+                      <a:pPr algn="ctr">
+                        <a:defRPr sz="1000" b="1">
+                          <a:solidFill>
+                            <a:srgbClr val="0F172A"/>
+                          </a:solidFill>
+                          <a:latin typeface="Segoe UI"/>
+                        </a:defRPr>
+                      </a:pPr>
+                      <a:r>
+                        <a:t>~0%</a:t>
                       </a:r>
                     </a:p>
                   </a:txBody>
@@ -7733,7 +7789,7 @@
                         </a:defRPr>
                       </a:pPr>
                       <a:r>
-                        <a:t>94.1%</a:t>
+                        <a:t>70.6%</a:t>
                       </a:r>
                     </a:p>
                   </a:txBody>
@@ -7757,7 +7813,7 @@
                         </a:defRPr>
                       </a:pPr>
                       <a:r>
-                        <a:t>0.565</a:t>
+                        <a:t>0.390</a:t>
                       </a:r>
                     </a:p>
                   </a:txBody>
@@ -7781,7 +7837,55 @@
                         </a:defRPr>
                       </a:pPr>
                       <a:r>
-                        <a:t>0.927</a:t>
+                        <a:t>0.775</a:t>
+                      </a:r>
+                    </a:p>
+                  </a:txBody>
+                  <a:tcPr>
+                    <a:solidFill>
+                      <a:srgbClr val="F8FAFC"/>
+                    </a:solidFill>
+                  </a:tcPr>
+                </a:tc>
+                <a:tc>
+                  <a:txBody>
+                    <a:bodyPr/>
+                    <a:lstStyle/>
+                    <a:p>
+                      <a:pPr algn="ctr">
+                        <a:defRPr sz="1000" b="0">
+                          <a:solidFill>
+                            <a:srgbClr val="334155"/>
+                          </a:solidFill>
+                          <a:latin typeface="Segoe UI"/>
+                        </a:defRPr>
+                      </a:pPr>
+                      <a:r>
+                        <a:t>81%</a:t>
+                      </a:r>
+                    </a:p>
+                  </a:txBody>
+                  <a:tcPr>
+                    <a:solidFill>
+                      <a:srgbClr val="F8FAFC"/>
+                    </a:solidFill>
+                  </a:tcPr>
+                </a:tc>
+                <a:tc>
+                  <a:txBody>
+                    <a:bodyPr/>
+                    <a:lstStyle/>
+                    <a:p>
+                      <a:pPr algn="ctr">
+                        <a:defRPr sz="1000" b="0">
+                          <a:solidFill>
+                            <a:srgbClr val="334155"/>
+                          </a:solidFill>
+                          <a:latin typeface="Segoe UI"/>
+                        </a:defRPr>
+                      </a:pPr>
+                      <a:r>
+                        <a:t>9%</a:t>
                       </a:r>
                     </a:p>
                   </a:txBody>
@@ -7831,7 +7935,7 @@
                         </a:defRPr>
                       </a:pPr>
                       <a:r>
-                        <a:t>94.4%</a:t>
+                        <a:t>70.3%</a:t>
                       </a:r>
                     </a:p>
                   </a:txBody>
@@ -7855,7 +7959,7 @@
                         </a:defRPr>
                       </a:pPr>
                       <a:r>
-                        <a:t>0.548</a:t>
+                        <a:t>0.385</a:t>
                       </a:r>
                     </a:p>
                   </a:txBody>
@@ -7879,7 +7983,55 @@
                         </a:defRPr>
                       </a:pPr>
                       <a:r>
-                        <a:t>0.936</a:t>
+                        <a:t>0.751</a:t>
+                      </a:r>
+                    </a:p>
+                  </a:txBody>
+                  <a:tcPr>
+                    <a:solidFill>
+                      <a:srgbClr val="FFFFFF"/>
+                    </a:solidFill>
+                  </a:tcPr>
+                </a:tc>
+                <a:tc>
+                  <a:txBody>
+                    <a:bodyPr/>
+                    <a:lstStyle/>
+                    <a:p>
+                      <a:pPr algn="ctr">
+                        <a:defRPr sz="1000" b="0">
+                          <a:solidFill>
+                            <a:srgbClr val="334155"/>
+                          </a:solidFill>
+                          <a:latin typeface="Segoe UI"/>
+                        </a:defRPr>
+                      </a:pPr>
+                      <a:r>
+                        <a:t>75%</a:t>
+                      </a:r>
+                    </a:p>
+                  </a:txBody>
+                  <a:tcPr>
+                    <a:solidFill>
+                      <a:srgbClr val="FFFFFF"/>
+                    </a:solidFill>
+                  </a:tcPr>
+                </a:tc>
+                <a:tc>
+                  <a:txBody>
+                    <a:bodyPr/>
+                    <a:lstStyle/>
+                    <a:p>
+                      <a:pPr algn="ctr">
+                        <a:defRPr sz="1000" b="0">
+                          <a:solidFill>
+                            <a:srgbClr val="334155"/>
+                          </a:solidFill>
+                          <a:latin typeface="Segoe UI"/>
+                        </a:defRPr>
+                      </a:pPr>
+                      <a:r>
+                        <a:t>9%</a:t>
                       </a:r>
                     </a:p>
                   </a:txBody>
@@ -7929,7 +8081,7 @@
                         </a:defRPr>
                       </a:pPr>
                       <a:r>
-                        <a:t>92.1%</a:t>
+                        <a:t>64.8%</a:t>
                       </a:r>
                     </a:p>
                   </a:txBody>
@@ -7953,7 +8105,7 @@
                         </a:defRPr>
                       </a:pPr>
                       <a:r>
-                        <a:t>0.549</a:t>
+                        <a:t>0.384</a:t>
                       </a:r>
                     </a:p>
                   </a:txBody>
@@ -7977,7 +8129,55 @@
                         </a:defRPr>
                       </a:pPr>
                       <a:r>
-                        <a:t>0.924</a:t>
+                        <a:t>0.754</a:t>
+                      </a:r>
+                    </a:p>
+                  </a:txBody>
+                  <a:tcPr>
+                    <a:solidFill>
+                      <a:srgbClr val="F8FAFC"/>
+                    </a:solidFill>
+                  </a:tcPr>
+                </a:tc>
+                <a:tc>
+                  <a:txBody>
+                    <a:bodyPr/>
+                    <a:lstStyle/>
+                    <a:p>
+                      <a:pPr algn="ctr">
+                        <a:defRPr sz="1000" b="0">
+                          <a:solidFill>
+                            <a:srgbClr val="334155"/>
+                          </a:solidFill>
+                          <a:latin typeface="Segoe UI"/>
+                        </a:defRPr>
+                      </a:pPr>
+                      <a:r>
+                        <a:t>70%</a:t>
+                      </a:r>
+                    </a:p>
+                  </a:txBody>
+                  <a:tcPr>
+                    <a:solidFill>
+                      <a:srgbClr val="F8FAFC"/>
+                    </a:solidFill>
+                  </a:tcPr>
+                </a:tc>
+                <a:tc>
+                  <a:txBody>
+                    <a:bodyPr/>
+                    <a:lstStyle/>
+                    <a:p>
+                      <a:pPr algn="ctr">
+                        <a:defRPr sz="1000" b="0">
+                          <a:solidFill>
+                            <a:srgbClr val="334155"/>
+                          </a:solidFill>
+                          <a:latin typeface="Segoe UI"/>
+                        </a:defRPr>
+                      </a:pPr>
+                      <a:r>
+                        <a:t>34%</a:t>
                       </a:r>
                     </a:p>
                   </a:txBody>
@@ -8027,7 +8227,7 @@
                         </a:defRPr>
                       </a:pPr>
                       <a:r>
-                        <a:t>80.8%</a:t>
+                        <a:t>54.8%</a:t>
                       </a:r>
                     </a:p>
                   </a:txBody>
@@ -8051,7 +8251,7 @@
                         </a:defRPr>
                       </a:pPr>
                       <a:r>
-                        <a:t>0.522</a:t>
+                        <a:t>0.354</a:t>
                       </a:r>
                     </a:p>
                   </a:txBody>
@@ -8075,7 +8275,55 @@
                         </a:defRPr>
                       </a:pPr>
                       <a:r>
-                        <a:t>0.926</a:t>
+                        <a:t>0.764</a:t>
+                      </a:r>
+                    </a:p>
+                  </a:txBody>
+                  <a:tcPr>
+                    <a:solidFill>
+                      <a:srgbClr val="FFFFFF"/>
+                    </a:solidFill>
+                  </a:tcPr>
+                </a:tc>
+                <a:tc>
+                  <a:txBody>
+                    <a:bodyPr/>
+                    <a:lstStyle/>
+                    <a:p>
+                      <a:pPr algn="ctr">
+                        <a:defRPr sz="1000" b="0">
+                          <a:solidFill>
+                            <a:srgbClr val="334155"/>
+                          </a:solidFill>
+                          <a:latin typeface="Segoe UI"/>
+                        </a:defRPr>
+                      </a:pPr>
+                      <a:r>
+                        <a:t>49%</a:t>
+                      </a:r>
+                    </a:p>
+                  </a:txBody>
+                  <a:tcPr>
+                    <a:solidFill>
+                      <a:srgbClr val="FFFFFF"/>
+                    </a:solidFill>
+                  </a:tcPr>
+                </a:tc>
+                <a:tc>
+                  <a:txBody>
+                    <a:bodyPr/>
+                    <a:lstStyle/>
+                    <a:p>
+                      <a:pPr algn="ctr">
+                        <a:defRPr sz="1000" b="0">
+                          <a:solidFill>
+                            <a:srgbClr val="334155"/>
+                          </a:solidFill>
+                          <a:latin typeface="Segoe UI"/>
+                        </a:defRPr>
+                      </a:pPr>
+                      <a:r>
+                        <a:t>50%</a:t>
                       </a:r>
                     </a:p>
                   </a:txBody>
@@ -8352,7 +8600,7 @@
               </a:defRPr>
             </a:pPr>
             <a:r>
-              <a:t>Moringa School Capstone  •  The Insight Architects  •  18 / 24</a:t>
+              <a:t>Moringa School Capstone  •  The Insight Architects  •  18 / 28</a:t>
             </a:r>
           </a:p>
         </p:txBody>
@@ -8473,7 +8721,7 @@
               </a:defRPr>
             </a:pPr>
             <a:r>
-              <a:t>All 5 models evaluated on identical test set: Confusion Matrix • ROC Curves • PR Curves • Model-specific diagnostics</a:t>
+              <a:t>5 models × 4 panels: Model-specific diagnostic • Confusion Matrix • ROC Curves • PR Curves</a:t>
             </a:r>
           </a:p>
         </p:txBody>
@@ -8652,7 +8900,7 @@
               </a:defRPr>
             </a:pPr>
             <a:r>
-              <a:t>Final Model: LightGBM (Selected for Deployment)</a:t>
+              <a:t>Deep Learning Benchmarks</a:t>
             </a:r>
           </a:p>
         </p:txBody>
@@ -8740,7 +8988,7 @@
               </a:defRPr>
             </a:pPr>
             <a:r>
-              <a:t>Moringa School Capstone  •  The Insight Architects  •  19 / 24</a:t>
+              <a:t>Moringa School Capstone  •  The Insight Architects  •  19 / 28</a:t>
             </a:r>
           </a:p>
         </p:txBody>
@@ -8837,7 +9085,7 @@
               </a:defRPr>
             </a:pPr>
             <a:r>
-              <a:t>Performance Summary</a:t>
+              <a:t>Deep MLP (4-Layer PyTorch)</a:t>
             </a:r>
           </a:p>
           <a:p>
@@ -8859,7 +9107,7 @@
               </a:defRPr>
             </a:pPr>
             <a:r>
-              <a:t>Accuracy: 95.8%  (best of all 5 models)</a:t>
+              <a:t>Linear(126→256)+BN+ReLU+Dropout × 3 layers + output head.</a:t>
             </a:r>
           </a:p>
           <a:p>
@@ -8881,7 +9129,7 @@
               </a:defRPr>
             </a:pPr>
             <a:r>
-              <a:t>Macro-AUC: 0.951  (best of all 5 models)</a:t>
+              <a:t>Accuracy: 70.3%, Modern recall: 75%</a:t>
             </a:r>
           </a:p>
           <a:p>
@@ -8903,7 +9151,29 @@
               </a:defRPr>
             </a:pPr>
             <a:r>
-              <a:t>Modern Recall: 100%</a:t>
+              <a:t>Macro-AUC: 0.751 — discrete survey data limits neural gains</a:t>
+            </a:r>
+          </a:p>
+          <a:p>
+            <a:pPr>
+              <a:lnSpc>
+                <a:spcPct val="110000"/>
+              </a:lnSpc>
+              <a:spcBef>
+                <a:spcPts val="800"/>
+              </a:spcBef>
+              <a:spcAft>
+                <a:spcPts val="300"/>
+              </a:spcAft>
+              <a:defRPr sz="1400" b="1" i="0">
+                <a:solidFill>
+                  <a:srgbClr val="0D9488"/>
+                </a:solidFill>
+                <a:latin typeface="Segoe UI"/>
+              </a:defRPr>
+            </a:pPr>
+            <a:r>
+              <a:t>TabTransformer (Self-Attention)</a:t>
             </a:r>
           </a:p>
           <a:p>
@@ -8925,7 +9195,7 @@
               </a:defRPr>
             </a:pPr>
             <a:r>
-              <a:t>No-method Recall: 99%</a:t>
+              <a:t>13 categorical embeddings (16-dim) + 2-head self-attention.</a:t>
             </a:r>
           </a:p>
           <a:p>
@@ -8947,7 +9217,29 @@
               </a:defRPr>
             </a:pPr>
             <a:r>
-              <a:t>Traditional Recall: 5% (rare-class suppression)</a:t>
+              <a:t>Accuracy: 64.8%, but Traditional recall: 34% (highest of all models)</a:t>
+            </a:r>
+          </a:p>
+          <a:p>
+            <a:pPr>
+              <a:lnSpc>
+                <a:spcPct val="115000"/>
+              </a:lnSpc>
+              <a:spcBef>
+                <a:spcPts val="200"/>
+              </a:spcBef>
+              <a:spcAft>
+                <a:spcPts val="400"/>
+              </a:spcAft>
+              <a:defRPr sz="1100" b="0" i="0">
+                <a:solidFill>
+                  <a:srgbClr val="334155"/>
+                </a:solidFill>
+                <a:latin typeface="Segoe UI"/>
+              </a:defRPr>
+            </a:pPr>
+            <a:r>
+              <a:t>Attention captures religion × county × union-status interactions</a:t>
             </a:r>
           </a:p>
           <a:p>
@@ -8969,7 +9261,7 @@
               </a:defRPr>
             </a:pPr>
             <a:r>
-              <a:t>Training Behavior</a:t>
+              <a:t>Verdict</a:t>
             </a:r>
           </a:p>
           <a:p>
@@ -8991,51 +9283,7 @@
               </a:defRPr>
             </a:pPr>
             <a:r>
-              <a:t>Validation loss plateaued, confirming no overfitting.</a:t>
-            </a:r>
-          </a:p>
-          <a:p>
-            <a:pPr>
-              <a:lnSpc>
-                <a:spcPct val="110000"/>
-              </a:lnSpc>
-              <a:spcBef>
-                <a:spcPts val="800"/>
-              </a:spcBef>
-              <a:spcAft>
-                <a:spcPts val="300"/>
-              </a:spcAft>
-              <a:defRPr sz="1400" b="1" i="0">
-                <a:solidFill>
-                  <a:srgbClr val="0D9488"/>
-                </a:solidFill>
-                <a:latin typeface="Segoe UI"/>
-              </a:defRPr>
-            </a:pPr>
-            <a:r>
-              <a:t>Rare-Class Limitation</a:t>
-            </a:r>
-          </a:p>
-          <a:p>
-            <a:pPr>
-              <a:lnSpc>
-                <a:spcPct val="115000"/>
-              </a:lnSpc>
-              <a:spcBef>
-                <a:spcPts val="200"/>
-              </a:spcBef>
-              <a:spcAft>
-                <a:spcPts val="400"/>
-              </a:spcAft>
-              <a:defRPr sz="1100" b="0" i="0">
-                <a:solidFill>
-                  <a:srgbClr val="334155"/>
-                </a:solidFill>
-                <a:latin typeface="Segoe UI"/>
-              </a:defRPr>
-            </a:pPr>
-            <a:r>
-              <a:t>Gradient boosting downweights rare-class residuals. Model works best as a binary risk flag.</a:t>
+              <a:t>TabTransformer promising for future work with more data.</a:t>
             </a:r>
           </a:p>
         </p:txBody>
@@ -9092,30 +9340,205 @@
           </a:p>
         </p:txBody>
       </p:sp>
-      <p:pic>
-        <p:nvPicPr>
-          <p:cNvPr id="10" name="Picture 9" descr="lgbm_evaluation_dashboard.png"/>
-          <p:cNvPicPr>
-            <a:picLocks noChangeAspect="1"/>
-          </p:cNvPicPr>
-          <p:nvPr/>
-        </p:nvPicPr>
-        <p:blipFill>
-          <a:blip r:embed="rId2"/>
-          <a:stretch>
-            <a:fillRect/>
-          </a:stretch>
-        </p:blipFill>
-        <p:spPr>
-          <a:xfrm>
-            <a:off x="6309360" y="2947939"/>
-            <a:ext cx="5059375" cy="1785081"/>
-          </a:xfrm>
-          <a:prstGeom prst="rect">
-            <a:avLst/>
-          </a:prstGeom>
-        </p:spPr>
-      </p:pic>
+      <p:sp>
+        <p:nvSpPr>
+          <p:cNvPr id="10" name="TextBox 9"/>
+          <p:cNvSpPr txBox="1"/>
+          <p:nvPr/>
+        </p:nvSpPr>
+        <p:spPr>
+          <a:xfrm>
+            <a:off x="6355080" y="1645920"/>
+            <a:ext cx="4967935" cy="4389120"/>
+          </a:xfrm>
+          <a:prstGeom prst="rect">
+            <a:avLst/>
+          </a:prstGeom>
+          <a:noFill/>
+        </p:spPr>
+        <p:txBody>
+          <a:bodyPr wrap="square" anchor="t">
+            <a:spAutoFit/>
+          </a:bodyPr>
+          <a:lstStyle/>
+          <a:p>
+            <a:pPr>
+              <a:lnSpc>
+                <a:spcPct val="110000"/>
+              </a:lnSpc>
+              <a:spcBef>
+                <a:spcPts val="800"/>
+              </a:spcBef>
+              <a:spcAft>
+                <a:spcPts val="300"/>
+              </a:spcAft>
+              <a:defRPr sz="1400" b="1" i="0">
+                <a:solidFill>
+                  <a:srgbClr val="0D9488"/>
+                </a:solidFill>
+                <a:latin typeface="Segoe UI"/>
+              </a:defRPr>
+            </a:pPr>
+            <a:r>
+              <a:t>TabTransformer Architecture</a:t>
+            </a:r>
+          </a:p>
+          <a:p>
+            <a:pPr>
+              <a:lnSpc>
+                <a:spcPct val="115000"/>
+              </a:lnSpc>
+              <a:spcBef>
+                <a:spcPts val="200"/>
+              </a:spcBef>
+              <a:spcAft>
+                <a:spcPts val="400"/>
+              </a:spcAft>
+              <a:defRPr sz="1100" b="0" i="0">
+                <a:solidFill>
+                  <a:srgbClr val="334155"/>
+                </a:solidFill>
+                <a:latin typeface="Segoe UI"/>
+              </a:defRPr>
+            </a:pPr>
+            <a:r>
+              <a:t>13 categorical embeddings (16-dim)</a:t>
+            </a:r>
+          </a:p>
+          <a:p>
+            <a:pPr>
+              <a:lnSpc>
+                <a:spcPct val="115000"/>
+              </a:lnSpc>
+              <a:spcBef>
+                <a:spcPts val="200"/>
+              </a:spcBef>
+              <a:spcAft>
+                <a:spcPts val="400"/>
+              </a:spcAft>
+              <a:defRPr sz="1100" b="0" i="0">
+                <a:solidFill>
+                  <a:srgbClr val="334155"/>
+                </a:solidFill>
+                <a:latin typeface="Segoe UI"/>
+              </a:defRPr>
+            </a:pPr>
+            <a:r>
+              <a:t>2-head self-attention layer</a:t>
+            </a:r>
+          </a:p>
+          <a:p>
+            <a:pPr>
+              <a:lnSpc>
+                <a:spcPct val="115000"/>
+              </a:lnSpc>
+              <a:spcBef>
+                <a:spcPts val="200"/>
+              </a:spcBef>
+              <a:spcAft>
+                <a:spcPts val="400"/>
+              </a:spcAft>
+              <a:defRPr sz="1100" b="0" i="0">
+                <a:solidFill>
+                  <a:srgbClr val="334155"/>
+                </a:solidFill>
+                <a:latin typeface="Segoe UI"/>
+              </a:defRPr>
+            </a:pPr>
+            <a:r>
+              <a:t>Concatenated with projected numerics</a:t>
+            </a:r>
+          </a:p>
+          <a:p>
+            <a:pPr>
+              <a:lnSpc>
+                <a:spcPct val="115000"/>
+              </a:lnSpc>
+              <a:spcBef>
+                <a:spcPts val="200"/>
+              </a:spcBef>
+              <a:spcAft>
+                <a:spcPts val="400"/>
+              </a:spcAft>
+              <a:defRPr sz="1100" b="0" i="0">
+                <a:solidFill>
+                  <a:srgbClr val="334155"/>
+                </a:solidFill>
+                <a:latin typeface="Segoe UI"/>
+              </a:defRPr>
+            </a:pPr>
+            <a:r>
+              <a:t>MLP classification head</a:t>
+            </a:r>
+          </a:p>
+          <a:p>
+            <a:pPr>
+              <a:lnSpc>
+                <a:spcPct val="115000"/>
+              </a:lnSpc>
+              <a:spcBef>
+                <a:spcPts val="200"/>
+              </a:spcBef>
+              <a:spcAft>
+                <a:spcPts val="400"/>
+              </a:spcAft>
+              <a:defRPr sz="1100" b="0" i="0">
+                <a:solidFill>
+                  <a:srgbClr val="334155"/>
+                </a:solidFill>
+                <a:latin typeface="Segoe UI"/>
+              </a:defRPr>
+            </a:pPr>
+            <a:r>
+              <a:t>43,044 total parameters</a:t>
+            </a:r>
+          </a:p>
+          <a:p>
+            <a:pPr>
+              <a:lnSpc>
+                <a:spcPct val="110000"/>
+              </a:lnSpc>
+              <a:spcBef>
+                <a:spcPts val="800"/>
+              </a:spcBef>
+              <a:spcAft>
+                <a:spcPts val="300"/>
+              </a:spcAft>
+              <a:defRPr sz="1400" b="1" i="0">
+                <a:solidFill>
+                  <a:srgbClr val="0D9488"/>
+                </a:solidFill>
+                <a:latin typeface="Segoe UI"/>
+              </a:defRPr>
+            </a:pPr>
+            <a:r>
+              <a:t>Why It Matters</a:t>
+            </a:r>
+          </a:p>
+          <a:p>
+            <a:pPr>
+              <a:lnSpc>
+                <a:spcPct val="115000"/>
+              </a:lnSpc>
+              <a:spcBef>
+                <a:spcPts val="200"/>
+              </a:spcBef>
+              <a:spcAft>
+                <a:spcPts val="400"/>
+              </a:spcAft>
+              <a:defRPr sz="1100" b="0" i="0">
+                <a:solidFill>
+                  <a:srgbClr val="334155"/>
+                </a:solidFill>
+                <a:latin typeface="Segoe UI"/>
+              </a:defRPr>
+            </a:pPr>
+            <a:r>
+              <a:t>LightGBM and RF predict Traditional at 0–9% recall. TabTransformer reaches 34% — showing attention learns complex multi-categorical interactions.</a:t>
+            </a:r>
+          </a:p>
+        </p:txBody>
+      </p:sp>
     </p:spTree>
   </p:cSld>
   <p:clrMapOvr>
@@ -9469,7 +9892,7 @@
               </a:defRPr>
             </a:pPr>
             <a:r>
-              <a:t>SHAP Panel A: High vs. Low Feature Groups</a:t>
+              <a:t>Final Model: LightGBM (Selected for Deployment)</a:t>
             </a:r>
           </a:p>
         </p:txBody>
@@ -9557,7 +9980,7 @@
               </a:defRPr>
             </a:pPr>
             <a:r>
-              <a:t>Moringa School Capstone  •  The Insight Architects  •  20 / 24</a:t>
+              <a:t>Moringa School Capstone  •  The Insight Architects  •  20 / 28</a:t>
             </a:r>
           </a:p>
         </p:txBody>
@@ -9654,7 +10077,7 @@
               </a:defRPr>
             </a:pPr>
             <a:r>
-              <a:t>What This Shows</a:t>
+              <a:t>Why LightGBM Was Chosen</a:t>
             </a:r>
           </a:p>
           <a:p>
@@ -9676,7 +10099,7 @@
               </a:defRPr>
             </a:pPr>
             <a:r>
-              <a:t>For each feature, the red dot shows the average SHAP value for women with HIGH values; blue dot for LOW values.</a:t>
+              <a:t>Best Macro-AUC (0.798), best accuracy (72.4%), native SHAP support, 5.6 MB bundle, sub-ms inference, no GPU.</a:t>
             </a:r>
           </a:p>
           <a:p>
@@ -9698,7 +10121,7 @@
               </a:defRPr>
             </a:pPr>
             <a:r>
-              <a:t>Key Findings</a:t>
+              <a:t>Hold-Out Performance (n=6,432)</a:t>
             </a:r>
           </a:p>
           <a:p>
@@ -9720,7 +10143,7 @@
               </a:defRPr>
             </a:pPr>
             <a:r>
-              <a:t>Age: strongest driver — older women pushed toward modern use</a:t>
+              <a:t>Accuracy: 72.4%</a:t>
             </a:r>
           </a:p>
           <a:p>
@@ -9742,7 +10165,7 @@
               </a:defRPr>
             </a:pPr>
             <a:r>
-              <a:t>Living children: adoption happens after having children</a:t>
+              <a:t>Macro-AUC: 0.798</a:t>
             </a:r>
           </a:p>
           <a:p>
@@ -9764,7 +10187,7 @@
               </a:defRPr>
             </a:pPr>
             <a:r>
-              <a:t>Employment: most policy-actionable lever</a:t>
+              <a:t>Macro-F1: 0.367</a:t>
             </a:r>
           </a:p>
           <a:p>
@@ -9786,7 +10209,95 @@
               </a:defRPr>
             </a:pPr>
             <a:r>
-              <a:t>is_in_union: strongest enabler of modern use</a:t>
+              <a:t>Modern Recall: 71%  |  No-method Recall: 78%</a:t>
+            </a:r>
+          </a:p>
+          <a:p>
+            <a:pPr>
+              <a:lnSpc>
+                <a:spcPct val="110000"/>
+              </a:lnSpc>
+              <a:spcBef>
+                <a:spcPts val="800"/>
+              </a:spcBef>
+              <a:spcAft>
+                <a:spcPts val="300"/>
+              </a:spcAft>
+              <a:defRPr sz="1400" b="1" i="0">
+                <a:solidFill>
+                  <a:srgbClr val="0D9488"/>
+                </a:solidFill>
+                <a:latin typeface="Segoe UI"/>
+              </a:defRPr>
+            </a:pPr>
+            <a:r>
+              <a:t>Learning Curve</a:t>
+            </a:r>
+          </a:p>
+          <a:p>
+            <a:pPr>
+              <a:lnSpc>
+                <a:spcPct val="115000"/>
+              </a:lnSpc>
+              <a:spcBef>
+                <a:spcPts val="200"/>
+              </a:spcBef>
+              <a:spcAft>
+                <a:spcPts val="400"/>
+              </a:spcAft>
+              <a:defRPr sz="1100" b="0" i="0">
+                <a:solidFill>
+                  <a:srgbClr val="334155"/>
+                </a:solidFill>
+                <a:latin typeface="Segoe UI"/>
+              </a:defRPr>
+            </a:pPr>
+            <a:r>
+              <a:t>Validation loss plateaued at iteration 226, confirming no overfitting despite SMOTE expansion.</a:t>
+            </a:r>
+          </a:p>
+          <a:p>
+            <a:pPr>
+              <a:lnSpc>
+                <a:spcPct val="110000"/>
+              </a:lnSpc>
+              <a:spcBef>
+                <a:spcPts val="800"/>
+              </a:spcBef>
+              <a:spcAft>
+                <a:spcPts val="300"/>
+              </a:spcAft>
+              <a:defRPr sz="1400" b="1" i="0">
+                <a:solidFill>
+                  <a:srgbClr val="0D9488"/>
+                </a:solidFill>
+                <a:latin typeface="Segoe UI"/>
+              </a:defRPr>
+            </a:pPr>
+            <a:r>
+              <a:t>Success Criteria Gap</a:t>
+            </a:r>
+          </a:p>
+          <a:p>
+            <a:pPr>
+              <a:lnSpc>
+                <a:spcPct val="115000"/>
+              </a:lnSpc>
+              <a:spcBef>
+                <a:spcPts val="200"/>
+              </a:spcBef>
+              <a:spcAft>
+                <a:spcPts val="400"/>
+              </a:spcAft>
+              <a:defRPr sz="1100" b="0" i="0">
+                <a:solidFill>
+                  <a:srgbClr val="334155"/>
+                </a:solidFill>
+                <a:latin typeface="Segoe UI"/>
+              </a:defRPr>
+            </a:pPr>
+            <a:r>
+              <a:t>Planned: Acc ≥ 78%, AUC ≥ 0.82, F1 ≥ 0.75. Shortfalls trace to the Folkloric/Traditional long tail. On binary Modern vs No-method: AUC = 0.823 / 0.834.</a:t>
             </a:r>
           </a:p>
         </p:txBody>
@@ -9845,7 +10356,7 @@
       </p:sp>
       <p:pic>
         <p:nvPicPr>
-          <p:cNvPr id="10" name="Picture 9" descr="shap_high_vs_low.png"/>
+          <p:cNvPr id="10" name="Picture 9" descr="lgbm_evaluation_dashboard.png"/>
           <p:cNvPicPr>
             <a:picLocks noChangeAspect="1"/>
           </p:cNvPicPr>
@@ -9859,8 +10370,8 @@
         </p:blipFill>
         <p:spPr>
           <a:xfrm>
-            <a:off x="6309360" y="2313894"/>
-            <a:ext cx="5059375" cy="3053171"/>
+            <a:off x="6309360" y="2947939"/>
+            <a:ext cx="5059375" cy="1785081"/>
           </a:xfrm>
           <a:prstGeom prst="rect">
             <a:avLst/>
@@ -10041,7 +10552,7 @@
               </a:defRPr>
             </a:pPr>
             <a:r>
-              <a:t>SHAP Panel B: Global Feature Importance</a:t>
+              <a:t>SHAP Panel A: High vs. Low Feature Groups</a:t>
             </a:r>
           </a:p>
         </p:txBody>
@@ -10129,7 +10640,7 @@
               </a:defRPr>
             </a:pPr>
             <a:r>
-              <a:t>Moringa School Capstone  •  The Insight Architects  •  21 / 24</a:t>
+              <a:t>Moringa School Capstone  •  The Insight Architects  •  21 / 28</a:t>
             </a:r>
           </a:p>
         </p:txBody>
@@ -10248,7 +10759,7 @@
               </a:defRPr>
             </a:pPr>
             <a:r>
-              <a:t>Average absolute SHAP value for each feature across all classes and samples.</a:t>
+              <a:t>For each feature, red dot = HIGH value SHAP, blue dot = LOW value. Gap = discriminative power.</a:t>
             </a:r>
           </a:p>
           <a:p>
@@ -10270,7 +10781,7 @@
               </a:defRPr>
             </a:pPr>
             <a:r>
-              <a:t>Top Drivers (Ranked)</a:t>
+              <a:t>Key Drivers (SHAP weights from notebook)</a:t>
             </a:r>
           </a:p>
           <a:p>
@@ -10292,7 +10803,7 @@
               </a:defRPr>
             </a:pPr>
             <a:r>
-              <a:t>Age — by far the strongest overall</a:t>
+              <a:t>Age (0.271): strongest driver. Older → modern use.</a:t>
             </a:r>
           </a:p>
           <a:p>
@@ -10314,7 +10825,7 @@
               </a:defRPr>
             </a:pPr>
             <a:r>
-              <a:t>Living children</a:t>
+              <a:t>Living children (0.224): adoption after having children.</a:t>
             </a:r>
           </a:p>
           <a:p>
@@ -10336,7 +10847,7 @@
               </a:defRPr>
             </a:pPr>
             <a:r>
-              <a:t>Region/County (arid_county, region dummies)</a:t>
+              <a:t>Employed (0.155): most policy-actionable lever.</a:t>
             </a:r>
           </a:p>
           <a:p>
@@ -10358,7 +10869,7 @@
               </a:defRPr>
             </a:pPr>
             <a:r>
-              <a:t>Employment status</a:t>
+              <a:t>Arid county (0.096): structural infrastructure barrier persists after controlling for wealth, education, religion.</a:t>
             </a:r>
           </a:p>
           <a:p>
@@ -10380,29 +10891,7 @@
               </a:defRPr>
             </a:pPr>
             <a:r>
-              <a:t>is_in_union / marital status</a:t>
-            </a:r>
-          </a:p>
-          <a:p>
-            <a:pPr>
-              <a:lnSpc>
-                <a:spcPct val="115000"/>
-              </a:lnSpc>
-              <a:spcBef>
-                <a:spcPts val="200"/>
-              </a:spcBef>
-              <a:spcAft>
-                <a:spcPts val="400"/>
-              </a:spcAft>
-              <a:defRPr sz="1100" b="0" i="0">
-                <a:solidFill>
-                  <a:srgbClr val="334155"/>
-                </a:solidFill>
-                <a:latin typeface="Segoe UI"/>
-              </a:defRPr>
-            </a:pPr>
-            <a:r>
-              <a:t>Age and living_children are universal discriminators across all four classes.</a:t>
+              <a:t>is_in_union: clearest single enabler of modern use.</a:t>
             </a:r>
           </a:p>
         </p:txBody>
@@ -10461,7 +10950,7 @@
       </p:sp>
       <p:pic>
         <p:nvPicPr>
-          <p:cNvPr id="10" name="Picture 9" descr="shap_global_bar.png"/>
+          <p:cNvPr id="10" name="Picture 9" descr="shap_high_vs_low.png"/>
           <p:cNvPicPr>
             <a:picLocks noChangeAspect="1"/>
           </p:cNvPicPr>
@@ -10475,8 +10964,8 @@
         </p:blipFill>
         <p:spPr>
           <a:xfrm>
-            <a:off x="6309360" y="2315668"/>
-            <a:ext cx="5059375" cy="3049623"/>
+            <a:off x="6309360" y="2313894"/>
+            <a:ext cx="5059375" cy="3053171"/>
           </a:xfrm>
           <a:prstGeom prst="rect">
             <a:avLst/>
@@ -10657,7 +11146,7 @@
               </a:defRPr>
             </a:pPr>
             <a:r>
-              <a:t>SHAP Panels C &amp; D: Two Real Women</a:t>
+              <a:t>SHAP Panel B: Global Feature Importance</a:t>
             </a:r>
           </a:p>
         </p:txBody>
@@ -10745,7 +11234,7 @@
               </a:defRPr>
             </a:pPr>
             <a:r>
-              <a:t>Moringa School Capstone  •  The Insight Architects  •  22 / 24</a:t>
+              <a:t>Moringa School Capstone  •  The Insight Architects  •  22 / 28</a:t>
             </a:r>
           </a:p>
         </p:txBody>
@@ -10842,7 +11331,7 @@
               </a:defRPr>
             </a:pPr>
             <a:r>
-              <a:t>Respondent C (“No method”, p=0.9994)</a:t>
+              <a:t>Mean |SHAP| Value Per Feature</a:t>
             </a:r>
           </a:p>
           <a:p>
@@ -10864,7 +11353,7 @@
               </a:defRPr>
             </a:pPr>
             <a:r>
-              <a:t>Young, never-married, zero children, no employment. Every feature pushes AWAY from modern use except marital status contributions.</a:t>
+              <a:t>Averaged across all four classes and 1,500 test respondents.</a:t>
             </a:r>
           </a:p>
           <a:p>
@@ -10886,7 +11375,7 @@
               </a:defRPr>
             </a:pPr>
             <a:r>
-              <a:t>Respondent D (“Modern”, p=1.0000)</a:t>
+              <a:t>Ranking</a:t>
             </a:r>
           </a:p>
           <a:p>
@@ -10908,29 +11397,7 @@
               </a:defRPr>
             </a:pPr>
             <a:r>
-              <a:t>Older, married, multiple children, employed. Age and living_children are the dominant positive drivers.</a:t>
-            </a:r>
-          </a:p>
-          <a:p>
-            <a:pPr>
-              <a:lnSpc>
-                <a:spcPct val="110000"/>
-              </a:lnSpc>
-              <a:spcBef>
-                <a:spcPts val="800"/>
-              </a:spcBef>
-              <a:spcAft>
-                <a:spcPts val="300"/>
-              </a:spcAft>
-              <a:defRPr sz="1400" b="1" i="0">
-                <a:solidFill>
-                  <a:srgbClr val="0D9488"/>
-                </a:solidFill>
-                <a:latin typeface="Segoe UI"/>
-              </a:defRPr>
-            </a:pPr>
-            <a:r>
-              <a:t>Implication</a:t>
+              <a:t>Age — by far the strongest overall (0.271)</a:t>
             </a:r>
           </a:p>
           <a:p>
@@ -10952,7 +11419,95 @@
               </a:defRPr>
             </a:pPr>
             <a:r>
-              <a:t>Individual-level explanations build trust with stakeholders and validate the model’s logic.</a:t>
+              <a:t>Living children (0.224)</a:t>
+            </a:r>
+          </a:p>
+          <a:p>
+            <a:pPr>
+              <a:lnSpc>
+                <a:spcPct val="115000"/>
+              </a:lnSpc>
+              <a:spcBef>
+                <a:spcPts val="200"/>
+              </a:spcBef>
+              <a:spcAft>
+                <a:spcPts val="400"/>
+              </a:spcAft>
+              <a:defRPr sz="1100" b="0" i="0">
+                <a:solidFill>
+                  <a:srgbClr val="334155"/>
+                </a:solidFill>
+                <a:latin typeface="Segoe UI"/>
+              </a:defRPr>
+            </a:pPr>
+            <a:r>
+              <a:t>Employment status (0.155)</a:t>
+            </a:r>
+          </a:p>
+          <a:p>
+            <a:pPr>
+              <a:lnSpc>
+                <a:spcPct val="115000"/>
+              </a:lnSpc>
+              <a:spcBef>
+                <a:spcPts val="200"/>
+              </a:spcBef>
+              <a:spcAft>
+                <a:spcPts val="400"/>
+              </a:spcAft>
+              <a:defRPr sz="1100" b="0" i="0">
+                <a:solidFill>
+                  <a:srgbClr val="334155"/>
+                </a:solidFill>
+                <a:latin typeface="Segoe UI"/>
+              </a:defRPr>
+            </a:pPr>
+            <a:r>
+              <a:t>Arid county (0.096)</a:t>
+            </a:r>
+          </a:p>
+          <a:p>
+            <a:pPr>
+              <a:lnSpc>
+                <a:spcPct val="115000"/>
+              </a:lnSpc>
+              <a:spcBef>
+                <a:spcPts val="200"/>
+              </a:spcBef>
+              <a:spcAft>
+                <a:spcPts val="400"/>
+              </a:spcAft>
+              <a:defRPr sz="1100" b="0" i="0">
+                <a:solidFill>
+                  <a:srgbClr val="334155"/>
+                </a:solidFill>
+                <a:latin typeface="Segoe UI"/>
+              </a:defRPr>
+            </a:pPr>
+            <a:r>
+              <a:t>Region / county dummies</a:t>
+            </a:r>
+          </a:p>
+          <a:p>
+            <a:pPr>
+              <a:lnSpc>
+                <a:spcPct val="115000"/>
+              </a:lnSpc>
+              <a:spcBef>
+                <a:spcPts val="200"/>
+              </a:spcBef>
+              <a:spcAft>
+                <a:spcPts val="400"/>
+              </a:spcAft>
+              <a:defRPr sz="1100" b="0" i="0">
+                <a:solidFill>
+                  <a:srgbClr val="334155"/>
+                </a:solidFill>
+                <a:latin typeface="Segoe UI"/>
+              </a:defRPr>
+            </a:pPr>
+            <a:r>
+              <a:t>Age and living_children are universal discriminators across all four classes.</a:t>
             </a:r>
           </a:p>
         </p:txBody>
@@ -11011,7 +11566,7 @@
       </p:sp>
       <p:pic>
         <p:nvPicPr>
-          <p:cNvPr id="10" name="Picture 9" descr="shap_waterfall_force.png"/>
+          <p:cNvPr id="10" name="Picture 9" descr="shap_global_bar.png"/>
           <p:cNvPicPr>
             <a:picLocks noChangeAspect="1"/>
           </p:cNvPicPr>
@@ -11025,8 +11580,8 @@
         </p:blipFill>
         <p:spPr>
           <a:xfrm>
-            <a:off x="6309360" y="2152454"/>
-            <a:ext cx="5059375" cy="3376051"/>
+            <a:off x="6309360" y="2315668"/>
+            <a:ext cx="5059375" cy="3049623"/>
           </a:xfrm>
           <a:prstGeom prst="rect">
             <a:avLst/>
@@ -11207,7 +11762,7 @@
               </a:defRPr>
             </a:pPr>
             <a:r>
-              <a:t>SHAP: Per-Class Breakdown &amp; Direction of Influence</a:t>
+              <a:t>SHAP Panels C &amp; D: Two Real Women</a:t>
             </a:r>
           </a:p>
         </p:txBody>
@@ -11295,7 +11850,7 @@
               </a:defRPr>
             </a:pPr>
             <a:r>
-              <a:t>Moringa School Capstone  •  The Insight Architects  •  23 / 24</a:t>
+              <a:t>Moringa School Capstone  •  The Insight Architects  •  23 / 28</a:t>
             </a:r>
           </a:p>
         </p:txBody>
@@ -11392,7 +11947,7 @@
               </a:defRPr>
             </a:pPr>
             <a:r>
-              <a:t>Per-Class Breakdown (Panel E)</a:t>
+              <a:t>Respondent C (“No method”, p=0.9994)</a:t>
             </a:r>
           </a:p>
           <a:p>
@@ -11414,7 +11969,29 @@
               </a:defRPr>
             </a:pPr>
             <a:r>
-              <a:t>Age and living_children are tall bars for every class — universal discriminators.</a:t>
+              <a:t>Young, never-married, zero children, no employment. Every feature pushes away from modern use.</a:t>
+            </a:r>
+          </a:p>
+          <a:p>
+            <a:pPr>
+              <a:lnSpc>
+                <a:spcPct val="110000"/>
+              </a:lnSpc>
+              <a:spcBef>
+                <a:spcPts val="800"/>
+              </a:spcBef>
+              <a:spcAft>
+                <a:spcPts val="300"/>
+              </a:spcAft>
+              <a:defRPr sz="1400" b="1" i="0">
+                <a:solidFill>
+                  <a:srgbClr val="0D9488"/>
+                </a:solidFill>
+                <a:latin typeface="Segoe UI"/>
+              </a:defRPr>
+            </a:pPr>
+            <a:r>
+              <a:t>Respondent D (“Modern”, p=1.0000)</a:t>
             </a:r>
           </a:p>
           <a:p>
@@ -11436,7 +12013,7 @@
               </a:defRPr>
             </a:pPr>
             <a:r>
-              <a:t>region and arid_county are disproportionately important for Traditional/Folkloric classes.</a:t>
+              <a:t>Older, married, multiple children, employed. Age and living_children are the dominant positive drivers.</a:t>
             </a:r>
           </a:p>
           <a:p>
@@ -11458,7 +12035,7 @@
               </a:defRPr>
             </a:pPr>
             <a:r>
-              <a:t>Direction Heatmap (Panel F)</a:t>
+              <a:t>Why This Matters</a:t>
             </a:r>
           </a:p>
           <a:p>
@@ -11480,51 +12057,7 @@
               </a:defRPr>
             </a:pPr>
             <a:r>
-              <a:t>is_in_union: deep red for Modern, blue for No-method — strongest enabler</a:t>
-            </a:r>
-          </a:p>
-          <a:p>
-            <a:pPr>
-              <a:lnSpc>
-                <a:spcPct val="115000"/>
-              </a:lnSpc>
-              <a:spcBef>
-                <a:spcPts val="200"/>
-              </a:spcBef>
-              <a:spcAft>
-                <a:spcPts val="400"/>
-              </a:spcAft>
-              <a:defRPr sz="1100" b="0" i="0">
-                <a:solidFill>
-                  <a:srgbClr val="334155"/>
-                </a:solidFill>
-                <a:latin typeface="Segoe UI"/>
-              </a:defRPr>
-            </a:pPr>
-            <a:r>
-              <a:t>arid_county: red for No-method, blue for Modern — infrastructure barrier</a:t>
-            </a:r>
-          </a:p>
-          <a:p>
-            <a:pPr>
-              <a:lnSpc>
-                <a:spcPct val="115000"/>
-              </a:lnSpc>
-              <a:spcBef>
-                <a:spcPts val="200"/>
-              </a:spcBef>
-              <a:spcAft>
-                <a:spcPts val="400"/>
-              </a:spcAft>
-              <a:defRPr sz="1100" b="0" i="0">
-                <a:solidFill>
-                  <a:srgbClr val="334155"/>
-                </a:solidFill>
-                <a:latin typeface="Segoe UI"/>
-              </a:defRPr>
-            </a:pPr>
-            <a:r>
-              <a:t>employed: enables Modern use, penalizes No-method</a:t>
+              <a:t>Individual-level explanations build stakeholder trust and validate the model’s logic against domain knowledge.</a:t>
             </a:r>
           </a:p>
         </p:txBody>
@@ -11583,7 +12116,7 @@
       </p:sp>
       <p:pic>
         <p:nvPicPr>
-          <p:cNvPr id="10" name="Picture 9" descr="shap_direction_heatmap.png"/>
+          <p:cNvPr id="10" name="Picture 9" descr="shap_waterfall_force.png"/>
           <p:cNvPicPr>
             <a:picLocks noChangeAspect="1"/>
           </p:cNvPicPr>
@@ -11597,8 +12130,8 @@
         </p:blipFill>
         <p:spPr>
           <a:xfrm>
-            <a:off x="6309360" y="2002602"/>
-            <a:ext cx="5059375" cy="3675756"/>
+            <a:off x="6309360" y="2152454"/>
+            <a:ext cx="5059375" cy="3376051"/>
           </a:xfrm>
           <a:prstGeom prst="rect">
             <a:avLst/>
@@ -11619,7 +12152,7 @@
     <p:bg>
       <p:bgPr>
         <a:solidFill>
-          <a:srgbClr val="0F172A"/>
+          <a:srgbClr val="F1F5F9"/>
         </a:solidFill>
         <a:effectLst/>
       </p:bgPr>
@@ -11639,8 +12172,8 @@
         </p:nvSpPr>
         <p:spPr>
           <a:xfrm>
-            <a:off x="0" y="3108960"/>
-            <a:ext cx="12191695" cy="54864"/>
+            <a:off x="0" y="0"/>
+            <a:ext cx="12191695" cy="73152"/>
           </a:xfrm>
           <a:prstGeom prst="rect">
             <a:avLst/>
@@ -11682,8 +12215,8 @@
         </p:nvSpPr>
         <p:spPr>
           <a:xfrm>
-            <a:off x="0" y="3163824"/>
-            <a:ext cx="12191695" cy="22860"/>
+            <a:off x="0" y="73152"/>
+            <a:ext cx="12191695" cy="27432"/>
           </a:xfrm>
           <a:prstGeom prst="rect">
             <a:avLst/>
@@ -11725,8 +12258,8 @@
         </p:nvSpPr>
         <p:spPr>
           <a:xfrm>
-            <a:off x="914400" y="2011680"/>
-            <a:ext cx="10332720" cy="1005840"/>
+            <a:off x="685800" y="201168"/>
+            <a:ext cx="10515600" cy="1188720"/>
           </a:xfrm>
           <a:prstGeom prst="rect">
             <a:avLst/>
@@ -11741,49 +12274,442 @@
           <a:p>
             <a:pPr>
               <a:lnSpc>
+                <a:spcPct val="100000"/>
+              </a:lnSpc>
+              <a:spcBef>
+                <a:spcPts val="0"/>
+              </a:spcBef>
+              <a:spcAft>
+                <a:spcPts val="200"/>
+              </a:spcAft>
+              <a:defRPr sz="900" b="1" i="0">
+                <a:solidFill>
+                  <a:srgbClr val="0D9488"/>
+                </a:solidFill>
+                <a:latin typeface="Segoe UI"/>
+              </a:defRPr>
+            </a:pPr>
+            <a:r>
+              <a:t>CAPSTONE PROJECT</a:t>
+            </a:r>
+          </a:p>
+          <a:p>
+            <a:pPr>
+              <a:lnSpc>
                 <a:spcPct val="105000"/>
               </a:lnSpc>
               <a:spcBef>
                 <a:spcPts val="0"/>
               </a:spcBef>
               <a:spcAft>
+                <a:spcPts val="0"/>
+              </a:spcAft>
+              <a:defRPr sz="2600" b="1" i="0">
+                <a:solidFill>
+                  <a:srgbClr val="0F172A"/>
+                </a:solidFill>
+                <a:latin typeface="Segoe UI"/>
+              </a:defRPr>
+            </a:pPr>
+            <a:r>
+              <a:t>SHAP: Per-Class Breakdown &amp; Direction of Influence</a:t>
+            </a:r>
+          </a:p>
+        </p:txBody>
+      </p:sp>
+      <p:sp>
+        <p:nvSpPr>
+          <p:cNvPr id="5" name="Rectangle 4"/>
+          <p:cNvSpPr/>
+          <p:nvPr/>
+        </p:nvSpPr>
+        <p:spPr>
+          <a:xfrm>
+            <a:off x="685800" y="6473952"/>
+            <a:ext cx="10820095" cy="13716"/>
+          </a:xfrm>
+          <a:prstGeom prst="rect">
+            <a:avLst/>
+          </a:prstGeom>
+          <a:solidFill>
+            <a:srgbClr val="E2E8F0"/>
+          </a:solidFill>
+          <a:ln>
+            <a:noFill/>
+          </a:ln>
+        </p:spPr>
+        <p:style>
+          <a:lnRef idx="1">
+            <a:schemeClr val="accent1"/>
+          </a:lnRef>
+          <a:fillRef idx="3">
+            <a:schemeClr val="accent1"/>
+          </a:fillRef>
+          <a:effectRef idx="2">
+            <a:schemeClr val="accent1"/>
+          </a:effectRef>
+          <a:fontRef idx="minor">
+            <a:schemeClr val="lt1"/>
+          </a:fontRef>
+        </p:style>
+        <p:txBody>
+          <a:bodyPr rtlCol="0" anchor="ctr"/>
+          <a:lstStyle/>
+          <a:p>
+            <a:pPr algn="ctr"/>
+          </a:p>
+        </p:txBody>
+      </p:sp>
+      <p:sp>
+        <p:nvSpPr>
+          <p:cNvPr id="6" name="TextBox 5"/>
+          <p:cNvSpPr txBox="1"/>
+          <p:nvPr/>
+        </p:nvSpPr>
+        <p:spPr>
+          <a:xfrm>
+            <a:off x="685800" y="6510528"/>
+            <a:ext cx="10817352" cy="320040"/>
+          </a:xfrm>
+          <a:prstGeom prst="rect">
+            <a:avLst/>
+          </a:prstGeom>
+          <a:noFill/>
+        </p:spPr>
+        <p:txBody>
+          <a:bodyPr wrap="square" anchor="t">
+            <a:spAutoFit/>
+          </a:bodyPr>
+          <a:lstStyle/>
+          <a:p>
+            <a:pPr>
+              <a:lnSpc>
+                <a:spcPct val="100000"/>
+              </a:lnSpc>
+              <a:spcBef>
+                <a:spcPts val="0"/>
+              </a:spcBef>
+              <a:spcAft>
+                <a:spcPts val="500"/>
+              </a:spcAft>
+              <a:defRPr sz="900" b="0" i="0">
+                <a:solidFill>
+                  <a:srgbClr val="64748B"/>
+                </a:solidFill>
+                <a:latin typeface="Segoe UI"/>
+              </a:defRPr>
+            </a:pPr>
+            <a:r>
+              <a:t>Moringa School Capstone  •  The Insight Architects  •  24 / 28</a:t>
+            </a:r>
+          </a:p>
+        </p:txBody>
+      </p:sp>
+      <p:sp>
+        <p:nvSpPr>
+          <p:cNvPr id="7" name="Rectangle 6"/>
+          <p:cNvSpPr/>
+          <p:nvPr/>
+        </p:nvSpPr>
+        <p:spPr>
+          <a:xfrm>
+            <a:off x="685800" y="1508760"/>
+            <a:ext cx="5120640" cy="4663440"/>
+          </a:xfrm>
+          <a:prstGeom prst="rect">
+            <a:avLst/>
+          </a:prstGeom>
+          <a:solidFill>
+            <a:srgbClr val="FFFFFF"/>
+          </a:solidFill>
+          <a:ln w="12700">
+            <a:solidFill>
+              <a:srgbClr val="E2E8F0"/>
+            </a:solidFill>
+          </a:ln>
+          <a:effectLst>
+            <a:outerShdw blurRad="76200" dist="38100" dir="5400000" algn="tl" rotWithShape="0">
+              <a:srgbClr val="000000">
+                <a:alpha val="23000"/>
+              </a:srgbClr>
+            </a:outerShdw>
+          </a:effectLst>
+        </p:spPr>
+        <p:style>
+          <a:lnRef idx="1">
+            <a:schemeClr val="accent1"/>
+          </a:lnRef>
+          <a:fillRef idx="3">
+            <a:schemeClr val="accent1"/>
+          </a:fillRef>
+          <a:effectRef idx="2">
+            <a:schemeClr val="accent1"/>
+          </a:effectRef>
+          <a:fontRef idx="minor">
+            <a:schemeClr val="lt1"/>
+          </a:fontRef>
+        </p:style>
+        <p:txBody>
+          <a:bodyPr rtlCol="0" anchor="ctr"/>
+          <a:lstStyle/>
+          <a:p>
+            <a:pPr algn="ctr"/>
+          </a:p>
+        </p:txBody>
+      </p:sp>
+      <p:sp>
+        <p:nvSpPr>
+          <p:cNvPr id="8" name="TextBox 7"/>
+          <p:cNvSpPr txBox="1"/>
+          <p:nvPr/>
+        </p:nvSpPr>
+        <p:spPr>
+          <a:xfrm>
+            <a:off x="868680" y="1645920"/>
+            <a:ext cx="4754880" cy="4389120"/>
+          </a:xfrm>
+          <a:prstGeom prst="rect">
+            <a:avLst/>
+          </a:prstGeom>
+          <a:noFill/>
+        </p:spPr>
+        <p:txBody>
+          <a:bodyPr wrap="square" anchor="t">
+            <a:spAutoFit/>
+          </a:bodyPr>
+          <a:lstStyle/>
+          <a:p>
+            <a:pPr>
+              <a:lnSpc>
+                <a:spcPct val="110000"/>
+              </a:lnSpc>
+              <a:spcBef>
+                <a:spcPts val="800"/>
+              </a:spcBef>
+              <a:spcAft>
+                <a:spcPts val="300"/>
+              </a:spcAft>
+              <a:defRPr sz="1400" b="1" i="0">
+                <a:solidFill>
+                  <a:srgbClr val="0D9488"/>
+                </a:solidFill>
+                <a:latin typeface="Segoe UI"/>
+              </a:defRPr>
+            </a:pPr>
+            <a:r>
+              <a:t>Per-Class Breakdown</a:t>
+            </a:r>
+          </a:p>
+          <a:p>
+            <a:pPr>
+              <a:lnSpc>
+                <a:spcPct val="115000"/>
+              </a:lnSpc>
+              <a:spcBef>
+                <a:spcPts val="200"/>
+              </a:spcBef>
+              <a:spcAft>
                 <a:spcPts val="400"/>
               </a:spcAft>
-              <a:defRPr sz="3600" b="1" i="0">
-                <a:solidFill>
-                  <a:srgbClr val="FFFFFF"/>
-                </a:solidFill>
-                <a:latin typeface="Segoe UI"/>
-              </a:defRPr>
-            </a:pPr>
-            <a:r>
-              <a:t>Deployment &amp; Recommendations</a:t>
-            </a:r>
-          </a:p>
-          <a:p>
-            <a:pPr>
-              <a:lnSpc>
-                <a:spcPct val="120000"/>
-              </a:lnSpc>
-              <a:spcBef>
-                <a:spcPts val="0"/>
-              </a:spcBef>
-              <a:spcAft>
-                <a:spcPts val="0"/>
-              </a:spcAft>
-              <a:defRPr sz="1600" b="0" i="0">
-                <a:solidFill>
-                  <a:srgbClr val="CBD5E1"/>
-                </a:solidFill>
-                <a:latin typeface="Segoe UI"/>
-              </a:defRPr>
-            </a:pPr>
-            <a:r>
-              <a:t>From model to actionable policy impact</a:t>
-            </a:r>
-          </a:p>
-        </p:txBody>
-      </p:sp>
+              <a:defRPr sz="1100" b="0" i="0">
+                <a:solidFill>
+                  <a:srgbClr val="334155"/>
+                </a:solidFill>
+                <a:latin typeface="Segoe UI"/>
+              </a:defRPr>
+            </a:pPr>
+            <a:r>
+              <a:t>Age and living_children are tall bars for every class — universal discriminators.</a:t>
+            </a:r>
+          </a:p>
+          <a:p>
+            <a:pPr>
+              <a:lnSpc>
+                <a:spcPct val="115000"/>
+              </a:lnSpc>
+              <a:spcBef>
+                <a:spcPts val="200"/>
+              </a:spcBef>
+              <a:spcAft>
+                <a:spcPts val="400"/>
+              </a:spcAft>
+              <a:defRPr sz="1100" b="0" i="0">
+                <a:solidFill>
+                  <a:srgbClr val="334155"/>
+                </a:solidFill>
+                <a:latin typeface="Segoe UI"/>
+              </a:defRPr>
+            </a:pPr>
+            <a:r>
+              <a:t>Region/arid_county are disproportionately important for Traditional/Folkloric classes.</a:t>
+            </a:r>
+          </a:p>
+          <a:p>
+            <a:pPr>
+              <a:lnSpc>
+                <a:spcPct val="110000"/>
+              </a:lnSpc>
+              <a:spcBef>
+                <a:spcPts val="800"/>
+              </a:spcBef>
+              <a:spcAft>
+                <a:spcPts val="300"/>
+              </a:spcAft>
+              <a:defRPr sz="1400" b="1" i="0">
+                <a:solidFill>
+                  <a:srgbClr val="0D9488"/>
+                </a:solidFill>
+                <a:latin typeface="Segoe UI"/>
+              </a:defRPr>
+            </a:pPr>
+            <a:r>
+              <a:t>Direction Heatmap</a:t>
+            </a:r>
+          </a:p>
+          <a:p>
+            <a:pPr>
+              <a:lnSpc>
+                <a:spcPct val="115000"/>
+              </a:lnSpc>
+              <a:spcBef>
+                <a:spcPts val="200"/>
+              </a:spcBef>
+              <a:spcAft>
+                <a:spcPts val="400"/>
+              </a:spcAft>
+              <a:defRPr sz="1100" b="0" i="0">
+                <a:solidFill>
+                  <a:srgbClr val="334155"/>
+                </a:solidFill>
+                <a:latin typeface="Segoe UI"/>
+              </a:defRPr>
+            </a:pPr>
+            <a:r>
+              <a:t>is_in_union: deep red for Modern, blue for No-method — strongest enabler</a:t>
+            </a:r>
+          </a:p>
+          <a:p>
+            <a:pPr>
+              <a:lnSpc>
+                <a:spcPct val="115000"/>
+              </a:lnSpc>
+              <a:spcBef>
+                <a:spcPts val="200"/>
+              </a:spcBef>
+              <a:spcAft>
+                <a:spcPts val="400"/>
+              </a:spcAft>
+              <a:defRPr sz="1100" b="0" i="0">
+                <a:solidFill>
+                  <a:srgbClr val="334155"/>
+                </a:solidFill>
+                <a:latin typeface="Segoe UI"/>
+              </a:defRPr>
+            </a:pPr>
+            <a:r>
+              <a:t>arid_county: red for No-method, blue for Modern — infrastructure barrier</a:t>
+            </a:r>
+          </a:p>
+          <a:p>
+            <a:pPr>
+              <a:lnSpc>
+                <a:spcPct val="115000"/>
+              </a:lnSpc>
+              <a:spcBef>
+                <a:spcPts val="200"/>
+              </a:spcBef>
+              <a:spcAft>
+                <a:spcPts val="400"/>
+              </a:spcAft>
+              <a:defRPr sz="1100" b="0" i="0">
+                <a:solidFill>
+                  <a:srgbClr val="334155"/>
+                </a:solidFill>
+                <a:latin typeface="Segoe UI"/>
+              </a:defRPr>
+            </a:pPr>
+            <a:r>
+              <a:t>employed: enables Modern, penalizes No-method</a:t>
+            </a:r>
+          </a:p>
+        </p:txBody>
+      </p:sp>
+      <p:sp>
+        <p:nvSpPr>
+          <p:cNvPr id="9" name="Rectangle 8"/>
+          <p:cNvSpPr/>
+          <p:nvPr/>
+        </p:nvSpPr>
+        <p:spPr>
+          <a:xfrm>
+            <a:off x="6172200" y="1508760"/>
+            <a:ext cx="5333695" cy="4663440"/>
+          </a:xfrm>
+          <a:prstGeom prst="rect">
+            <a:avLst/>
+          </a:prstGeom>
+          <a:solidFill>
+            <a:srgbClr val="FFFFFF"/>
+          </a:solidFill>
+          <a:ln w="12700">
+            <a:solidFill>
+              <a:srgbClr val="E2E8F0"/>
+            </a:solidFill>
+          </a:ln>
+          <a:effectLst>
+            <a:outerShdw blurRad="76200" dist="38100" dir="5400000" algn="tl" rotWithShape="0">
+              <a:srgbClr val="000000">
+                <a:alpha val="23000"/>
+              </a:srgbClr>
+            </a:outerShdw>
+          </a:effectLst>
+        </p:spPr>
+        <p:style>
+          <a:lnRef idx="1">
+            <a:schemeClr val="accent1"/>
+          </a:lnRef>
+          <a:fillRef idx="3">
+            <a:schemeClr val="accent1"/>
+          </a:fillRef>
+          <a:effectRef idx="2">
+            <a:schemeClr val="accent1"/>
+          </a:effectRef>
+          <a:fontRef idx="minor">
+            <a:schemeClr val="lt1"/>
+          </a:fontRef>
+        </p:style>
+        <p:txBody>
+          <a:bodyPr rtlCol="0" anchor="ctr"/>
+          <a:lstStyle/>
+          <a:p>
+            <a:pPr algn="ctr"/>
+          </a:p>
+        </p:txBody>
+      </p:sp>
+      <p:pic>
+        <p:nvPicPr>
+          <p:cNvPr id="10" name="Picture 9" descr="shap_direction_heatmap.png"/>
+          <p:cNvPicPr>
+            <a:picLocks noChangeAspect="1"/>
+          </p:cNvPicPr>
+          <p:nvPr/>
+        </p:nvPicPr>
+        <p:blipFill>
+          <a:blip r:embed="rId2"/>
+          <a:stretch>
+            <a:fillRect/>
+          </a:stretch>
+        </p:blipFill>
+        <p:spPr>
+          <a:xfrm>
+            <a:off x="6309360" y="2002602"/>
+            <a:ext cx="5059375" cy="3675756"/>
+          </a:xfrm>
+          <a:prstGeom prst="rect">
+            <a:avLst/>
+          </a:prstGeom>
+        </p:spPr>
+      </p:pic>
     </p:spTree>
   </p:cSld>
   <p:clrMapOvr>
@@ -11958,7 +12884,7 @@
               </a:defRPr>
             </a:pPr>
             <a:r>
-              <a:t>Deployment: Flask API on Render.com</a:t>
+              <a:t>Summary of Key Insights</a:t>
             </a:r>
           </a:p>
         </p:txBody>
@@ -12046,7 +12972,7 @@
               </a:defRPr>
             </a:pPr>
             <a:r>
-              <a:t>Moringa School Capstone  •  The Insight Architects  •  25 / 24</a:t>
+              <a:t>Moringa School Capstone  •  The Insight Architects  •  25 / 28</a:t>
             </a:r>
           </a:p>
         </p:txBody>
@@ -12060,7 +12986,7 @@
         <p:spPr>
           <a:xfrm>
             <a:off x="685800" y="1508760"/>
-            <a:ext cx="5120640" cy="4663440"/>
+            <a:ext cx="10607040" cy="4663440"/>
           </a:xfrm>
           <a:prstGeom prst="rect">
             <a:avLst/>
@@ -12112,7 +13038,7 @@
         <p:spPr>
           <a:xfrm>
             <a:off x="868680" y="1645920"/>
-            <a:ext cx="4754880" cy="4389120"/>
+            <a:ext cx="10241280" cy="4389120"/>
           </a:xfrm>
           <a:prstGeom prst="rect">
             <a:avLst/>
@@ -12143,7 +13069,7 @@
               </a:defRPr>
             </a:pPr>
             <a:r>
-              <a:t>Interactive Web Application</a:t>
+              <a:t>From the Notebook (10 Key Findings)</a:t>
             </a:r>
           </a:p>
           <a:p>
@@ -12165,29 +13091,7 @@
               </a:defRPr>
             </a:pPr>
             <a:r>
-              <a:t>Deployed on Render.com for stakeholders (Ministry of Health, CHPs, UNFPA).</a:t>
-            </a:r>
-          </a:p>
-          <a:p>
-            <a:pPr>
-              <a:lnSpc>
-                <a:spcPct val="110000"/>
-              </a:lnSpc>
-              <a:spcBef>
-                <a:spcPts val="800"/>
-              </a:spcBef>
-              <a:spcAft>
-                <a:spcPts val="300"/>
-              </a:spcAft>
-              <a:defRPr sz="1400" b="1" i="0">
-                <a:solidFill>
-                  <a:srgbClr val="0D9488"/>
-                </a:solidFill>
-                <a:latin typeface="Segoe UI"/>
-              </a:defRPr>
-            </a:pPr>
-            <a:r>
-              <a:t>Serve-Skew Prevention</a:t>
+              <a:t>1. Target is heavily imbalanced: 58.1% no method, 37.9% modern, 3.8% traditional, 0.2% folkloric.</a:t>
             </a:r>
           </a:p>
           <a:p>
@@ -12209,7 +13113,7 @@
               </a:defRPr>
             </a:pPr>
             <a:r>
-              <a:t>feature_engineering.py is a shared module imported by both the training notebook and Flask API.</a:t>
+              <a:t>2. County is the biggest signal: modern use 1% (Mandera) to 57% (Embu).</a:t>
             </a:r>
           </a:p>
           <a:p>
@@ -12231,29 +13135,7 @@
               </a:defRPr>
             </a:pPr>
             <a:r>
-              <a:t>Identical transformations guaranteed — mismatches structurally impossible.</a:t>
-            </a:r>
-          </a:p>
-          <a:p>
-            <a:pPr>
-              <a:lnSpc>
-                <a:spcPct val="110000"/>
-              </a:lnSpc>
-              <a:spcBef>
-                <a:spcPts val="800"/>
-              </a:spcBef>
-              <a:spcAft>
-                <a:spcPts val="300"/>
-              </a:spcAft>
-              <a:defRPr sz="1400" b="1" i="0">
-                <a:solidFill>
-                  <a:srgbClr val="0D9488"/>
-                </a:solidFill>
-                <a:latin typeface="Segoe UI"/>
-              </a:defRPr>
-            </a:pPr>
-            <a:r>
-              <a:t>Model Bundle</a:t>
+              <a:t>3. No education: ~12% modern use. Any education: 37–46%.</a:t>
             </a:r>
           </a:p>
           <a:p>
@@ -12275,104 +13157,7 @@
               </a:defRPr>
             </a:pPr>
             <a:r>
-              <a:t>Saved as contraceptive_model_bundle.joblib (5.62 MB) containing model + preprocessor + label encoder.</a:t>
-            </a:r>
-          </a:p>
-        </p:txBody>
-      </p:sp>
-      <p:sp>
-        <p:nvSpPr>
-          <p:cNvPr id="9" name="Rectangle 8"/>
-          <p:cNvSpPr/>
-          <p:nvPr/>
-        </p:nvSpPr>
-        <p:spPr>
-          <a:xfrm>
-            <a:off x="6172200" y="1508760"/>
-            <a:ext cx="5333695" cy="4663440"/>
-          </a:xfrm>
-          <a:prstGeom prst="rect">
-            <a:avLst/>
-          </a:prstGeom>
-          <a:solidFill>
-            <a:srgbClr val="FFFFFF"/>
-          </a:solidFill>
-          <a:ln w="12700">
-            <a:solidFill>
-              <a:srgbClr val="E2E8F0"/>
-            </a:solidFill>
-          </a:ln>
-          <a:effectLst>
-            <a:outerShdw blurRad="76200" dist="38100" dir="5400000" algn="tl" rotWithShape="0">
-              <a:srgbClr val="000000">
-                <a:alpha val="23000"/>
-              </a:srgbClr>
-            </a:outerShdw>
-          </a:effectLst>
-        </p:spPr>
-        <p:style>
-          <a:lnRef idx="1">
-            <a:schemeClr val="accent1"/>
-          </a:lnRef>
-          <a:fillRef idx="3">
-            <a:schemeClr val="accent1"/>
-          </a:fillRef>
-          <a:effectRef idx="2">
-            <a:schemeClr val="accent1"/>
-          </a:effectRef>
-          <a:fontRef idx="minor">
-            <a:schemeClr val="lt1"/>
-          </a:fontRef>
-        </p:style>
-        <p:txBody>
-          <a:bodyPr rtlCol="0" anchor="ctr"/>
-          <a:lstStyle/>
-          <a:p>
-            <a:pPr algn="ctr"/>
-          </a:p>
-        </p:txBody>
-      </p:sp>
-      <p:sp>
-        <p:nvSpPr>
-          <p:cNvPr id="10" name="TextBox 9"/>
-          <p:cNvSpPr txBox="1"/>
-          <p:nvPr/>
-        </p:nvSpPr>
-        <p:spPr>
-          <a:xfrm>
-            <a:off x="6355080" y="1645920"/>
-            <a:ext cx="4967935" cy="4389120"/>
-          </a:xfrm>
-          <a:prstGeom prst="rect">
-            <a:avLst/>
-          </a:prstGeom>
-          <a:noFill/>
-        </p:spPr>
-        <p:txBody>
-          <a:bodyPr wrap="square" anchor="t">
-            <a:spAutoFit/>
-          </a:bodyPr>
-          <a:lstStyle/>
-          <a:p>
-            <a:pPr>
-              <a:lnSpc>
-                <a:spcPct val="110000"/>
-              </a:lnSpc>
-              <a:spcBef>
-                <a:spcPts val="800"/>
-              </a:spcBef>
-              <a:spcAft>
-                <a:spcPts val="300"/>
-              </a:spcAft>
-              <a:defRPr sz="1400" b="1" i="0">
-                <a:solidFill>
-                  <a:srgbClr val="0D9488"/>
-                </a:solidFill>
-                <a:latin typeface="Segoe UI"/>
-              </a:defRPr>
-            </a:pPr>
-            <a:r>
-              <a:t>Flask API Endpoints</a:t>
+              <a:t>4. Wealth is a cliff: Poorest at 25%, flat at 41–43% above.</a:t>
             </a:r>
           </a:p>
           <a:p>
@@ -12381,50 +13166,20 @@
                 <a:spcPct val="115000"/>
               </a:lnSpc>
               <a:spcBef>
-                <a:spcPts val="300"/>
-              </a:spcBef>
-              <a:spcAft>
-                <a:spcPts val="600"/>
-              </a:spcAft>
-              <a:defRPr sz="1000" b="0" i="0">
-                <a:solidFill>
-                  <a:srgbClr val="0F172A"/>
-                </a:solidFill>
-                <a:latin typeface="Consolas"/>
-              </a:defRPr>
-            </a:pPr>
-            <a:r>
-              <a:t>GET  /         HTML Form Interface</a:t>
-            </a:r>
-            <a:br/>
-            <a:r>
-              <a:t>GET  /health   Server Healthcheck</a:t>
-            </a:r>
-            <a:br/>
-            <a:r>
-              <a:t>POST /predict  Single Prediction</a:t>
-            </a:r>
-          </a:p>
-          <a:p>
-            <a:pPr>
-              <a:lnSpc>
-                <a:spcPct val="110000"/>
-              </a:lnSpc>
-              <a:spcBef>
-                <a:spcPts val="800"/>
-              </a:spcBef>
-              <a:spcAft>
-                <a:spcPts val="300"/>
-              </a:spcAft>
-              <a:defRPr sz="1400" b="1" i="0">
-                <a:solidFill>
-                  <a:srgbClr val="0D9488"/>
-                </a:solidFill>
-                <a:latin typeface="Segoe UI"/>
-              </a:defRPr>
-            </a:pPr>
-            <a:r>
-              <a:t>Live URL</a:t>
+                <a:spcPts val="200"/>
+              </a:spcBef>
+              <a:spcAft>
+                <a:spcPts val="400"/>
+              </a:spcAft>
+              <a:defRPr sz="1100" b="0" i="0">
+                <a:solidFill>
+                  <a:srgbClr val="334155"/>
+                </a:solidFill>
+                <a:latin typeface="Segoe UI"/>
+              </a:defRPr>
+            </a:pPr>
+            <a:r>
+              <a:t>5. Residence barely matters: urban and rural both ~38%.</a:t>
             </a:r>
           </a:p>
           <a:p>
@@ -12446,7 +13201,7 @@
               </a:defRPr>
             </a:pPr>
             <a:r>
-              <a:t>kdhs-contraceptive-api.onrender.com</a:t>
+              <a:t>6. Education outweighs wealth across every wealth group.</a:t>
             </a:r>
           </a:p>
           <a:p>
@@ -12468,29 +13223,7 @@
               </a:defRPr>
             </a:pPr>
             <a:r>
-              <a:t>Auth: X-API-Key header required</a:t>
-            </a:r>
-          </a:p>
-          <a:p>
-            <a:pPr>
-              <a:lnSpc>
-                <a:spcPct val="110000"/>
-              </a:lnSpc>
-              <a:spcBef>
-                <a:spcPts val="800"/>
-              </a:spcBef>
-              <a:spcAft>
-                <a:spcPts val="300"/>
-              </a:spcAft>
-              <a:defRPr sz="1400" b="1" i="0">
-                <a:solidFill>
-                  <a:srgbClr val="0D9488"/>
-                </a:solidFill>
-                <a:latin typeface="Segoe UI"/>
-              </a:defRPr>
-            </a:pPr>
-            <a:r>
-              <a:t>Smoke Test Verified</a:t>
+              <a:t>7. children_ever_born and living_children: r=0.98, one dropped.</a:t>
             </a:r>
           </a:p>
           <a:p>
@@ -12512,7 +13245,51 @@
               </a:defRPr>
             </a:pPr>
             <a:r>
-              <a:t>End-to-end: raw JSON → feature_engineering → preprocessing → LightGBM → prediction → API response.</a:t>
+              <a:t>8. LightGBM selected: best accuracy 72.4%, best Macro-AUC 0.798.</a:t>
+            </a:r>
+          </a:p>
+          <a:p>
+            <a:pPr>
+              <a:lnSpc>
+                <a:spcPct val="115000"/>
+              </a:lnSpc>
+              <a:spcBef>
+                <a:spcPts val="200"/>
+              </a:spcBef>
+              <a:spcAft>
+                <a:spcPts val="400"/>
+              </a:spcAft>
+              <a:defRPr sz="1100" b="0" i="0">
+                <a:solidFill>
+                  <a:srgbClr val="334155"/>
+                </a:solidFill>
+                <a:latin typeface="Segoe UI"/>
+              </a:defRPr>
+            </a:pPr>
+            <a:r>
+              <a:t>9. RF has best Macro-F1 (0.390 vs 0.367) — tradeoff for minority classes.</a:t>
+            </a:r>
+          </a:p>
+          <a:p>
+            <a:pPr>
+              <a:lnSpc>
+                <a:spcPct val="115000"/>
+              </a:lnSpc>
+              <a:spcBef>
+                <a:spcPts val="200"/>
+              </a:spcBef>
+              <a:spcAft>
+                <a:spcPts val="400"/>
+              </a:spcAft>
+              <a:defRPr sz="1100" b="0" i="0">
+                <a:solidFill>
+                  <a:srgbClr val="334155"/>
+                </a:solidFill>
+                <a:latin typeface="Segoe UI"/>
+              </a:defRPr>
+            </a:pPr>
+            <a:r>
+              <a:t>10. SHAP: age strongest, then living children; is_in_union top enabler; arid_county structural barrier.</a:t>
             </a:r>
           </a:p>
         </p:txBody>
@@ -12526,6 +13303,185 @@
 </file>
 
 <file path=ppt/slides/slide26.xml><?xml version="1.0" encoding="utf-8"?>
+<p:sld xmlns:a="http://schemas.openxmlformats.org/drawingml/2006/main" xmlns:p="http://schemas.openxmlformats.org/presentationml/2006/main" xmlns:r="http://schemas.openxmlformats.org/officeDocument/2006/relationships">
+  <p:cSld>
+    <p:bg>
+      <p:bgPr>
+        <a:solidFill>
+          <a:srgbClr val="0F172A"/>
+        </a:solidFill>
+        <a:effectLst/>
+      </p:bgPr>
+    </p:bg>
+    <p:spTree>
+      <p:nvGrpSpPr>
+        <p:cNvPr id="1" name=""/>
+        <p:cNvGrpSpPr/>
+        <p:nvPr/>
+      </p:nvGrpSpPr>
+      <p:grpSpPr/>
+      <p:sp>
+        <p:nvSpPr>
+          <p:cNvPr id="2" name="Rectangle 1"/>
+          <p:cNvSpPr/>
+          <p:nvPr/>
+        </p:nvSpPr>
+        <p:spPr>
+          <a:xfrm>
+            <a:off x="0" y="3108960"/>
+            <a:ext cx="12191695" cy="54864"/>
+          </a:xfrm>
+          <a:prstGeom prst="rect">
+            <a:avLst/>
+          </a:prstGeom>
+          <a:solidFill>
+            <a:srgbClr val="0D9488"/>
+          </a:solidFill>
+          <a:ln>
+            <a:noFill/>
+          </a:ln>
+        </p:spPr>
+        <p:style>
+          <a:lnRef idx="1">
+            <a:schemeClr val="accent1"/>
+          </a:lnRef>
+          <a:fillRef idx="3">
+            <a:schemeClr val="accent1"/>
+          </a:fillRef>
+          <a:effectRef idx="2">
+            <a:schemeClr val="accent1"/>
+          </a:effectRef>
+          <a:fontRef idx="minor">
+            <a:schemeClr val="lt1"/>
+          </a:fontRef>
+        </p:style>
+        <p:txBody>
+          <a:bodyPr rtlCol="0" anchor="ctr"/>
+          <a:lstStyle/>
+          <a:p>
+            <a:pPr algn="ctr"/>
+          </a:p>
+        </p:txBody>
+      </p:sp>
+      <p:sp>
+        <p:nvSpPr>
+          <p:cNvPr id="3" name="Rectangle 2"/>
+          <p:cNvSpPr/>
+          <p:nvPr/>
+        </p:nvSpPr>
+        <p:spPr>
+          <a:xfrm>
+            <a:off x="0" y="3163824"/>
+            <a:ext cx="12191695" cy="22860"/>
+          </a:xfrm>
+          <a:prstGeom prst="rect">
+            <a:avLst/>
+          </a:prstGeom>
+          <a:solidFill>
+            <a:srgbClr val="D97706"/>
+          </a:solidFill>
+          <a:ln>
+            <a:noFill/>
+          </a:ln>
+        </p:spPr>
+        <p:style>
+          <a:lnRef idx="1">
+            <a:schemeClr val="accent1"/>
+          </a:lnRef>
+          <a:fillRef idx="3">
+            <a:schemeClr val="accent1"/>
+          </a:fillRef>
+          <a:effectRef idx="2">
+            <a:schemeClr val="accent1"/>
+          </a:effectRef>
+          <a:fontRef idx="minor">
+            <a:schemeClr val="lt1"/>
+          </a:fontRef>
+        </p:style>
+        <p:txBody>
+          <a:bodyPr rtlCol="0" anchor="ctr"/>
+          <a:lstStyle/>
+          <a:p>
+            <a:pPr algn="ctr"/>
+          </a:p>
+        </p:txBody>
+      </p:sp>
+      <p:sp>
+        <p:nvSpPr>
+          <p:cNvPr id="4" name="TextBox 3"/>
+          <p:cNvSpPr txBox="1"/>
+          <p:nvPr/>
+        </p:nvSpPr>
+        <p:spPr>
+          <a:xfrm>
+            <a:off x="914400" y="2011680"/>
+            <a:ext cx="10332720" cy="1005840"/>
+          </a:xfrm>
+          <a:prstGeom prst="rect">
+            <a:avLst/>
+          </a:prstGeom>
+          <a:noFill/>
+        </p:spPr>
+        <p:txBody>
+          <a:bodyPr wrap="square" anchor="t">
+            <a:spAutoFit/>
+          </a:bodyPr>
+          <a:lstStyle/>
+          <a:p>
+            <a:pPr>
+              <a:lnSpc>
+                <a:spcPct val="105000"/>
+              </a:lnSpc>
+              <a:spcBef>
+                <a:spcPts val="0"/>
+              </a:spcBef>
+              <a:spcAft>
+                <a:spcPts val="400"/>
+              </a:spcAft>
+              <a:defRPr sz="3600" b="1" i="0">
+                <a:solidFill>
+                  <a:srgbClr val="FFFFFF"/>
+                </a:solidFill>
+                <a:latin typeface="Segoe UI"/>
+              </a:defRPr>
+            </a:pPr>
+            <a:r>
+              <a:t>Deployment &amp; Recommendations</a:t>
+            </a:r>
+          </a:p>
+          <a:p>
+            <a:pPr>
+              <a:lnSpc>
+                <a:spcPct val="120000"/>
+              </a:lnSpc>
+              <a:spcBef>
+                <a:spcPts val="0"/>
+              </a:spcBef>
+              <a:spcAft>
+                <a:spcPts val="0"/>
+              </a:spcAft>
+              <a:defRPr sz="1600" b="0" i="0">
+                <a:solidFill>
+                  <a:srgbClr val="CBD5E1"/>
+                </a:solidFill>
+                <a:latin typeface="Segoe UI"/>
+              </a:defRPr>
+            </a:pPr>
+            <a:r>
+              <a:t>From model to actionable policy impact</a:t>
+            </a:r>
+          </a:p>
+        </p:txBody>
+      </p:sp>
+    </p:spTree>
+  </p:cSld>
+  <p:clrMapOvr>
+    <a:masterClrMapping/>
+  </p:clrMapOvr>
+</p:sld>
+</file>
+
+<file path=ppt/slides/slide27.xml><?xml version="1.0" encoding="utf-8"?>
 <p:sld xmlns:a="http://schemas.openxmlformats.org/drawingml/2006/main" xmlns:p="http://schemas.openxmlformats.org/presentationml/2006/main" xmlns:r="http://schemas.openxmlformats.org/officeDocument/2006/relationships">
   <p:cSld>
     <p:bg>
@@ -12691,7 +13647,7 @@
               </a:defRPr>
             </a:pPr>
             <a:r>
-              <a:t>Actionable Policy Recommendations</a:t>
+              <a:t>Deployment: Flask API on Render.com</a:t>
             </a:r>
           </a:p>
         </p:txBody>
@@ -12779,7 +13735,7 @@
               </a:defRPr>
             </a:pPr>
             <a:r>
-              <a:t>Moringa School Capstone  •  The Insight Architects  •  26 / 24</a:t>
+              <a:t>Moringa School Capstone  •  The Insight Architects  •  27 / 28</a:t>
             </a:r>
           </a:p>
         </p:txBody>
@@ -12793,7 +13749,7 @@
         <p:spPr>
           <a:xfrm>
             <a:off x="685800" y="1508760"/>
-            <a:ext cx="10607040" cy="4663440"/>
+            <a:ext cx="5120640" cy="4663440"/>
           </a:xfrm>
           <a:prstGeom prst="rect">
             <a:avLst/>
@@ -12845,7 +13801,7 @@
         <p:spPr>
           <a:xfrm>
             <a:off x="868680" y="1645920"/>
-            <a:ext cx="10241280" cy="4389120"/>
+            <a:ext cx="4754880" cy="4389120"/>
           </a:xfrm>
           <a:prstGeom prst="rect">
             <a:avLst/>
@@ -12876,7 +13832,7 @@
               </a:defRPr>
             </a:pPr>
             <a:r>
-              <a:t>1. Geographic Prioritization (ASAL Regions)</a:t>
+              <a:t>Interactive Web Application</a:t>
             </a:r>
           </a:p>
           <a:p>
@@ -12898,7 +13854,7 @@
               </a:defRPr>
             </a:pPr>
             <a:r>
-              <a:t>Mandera (1.2%), Wajir (2.8%), Garissa (4.5%) face systemic infrastructure barriers. Fund mobile clinics and supply chains.</a:t>
+              <a:t>Deployed on Render.com for stakeholders (MoH, CHPs, UNFPA, USAID Kenya, FP2030).</a:t>
             </a:r>
           </a:p>
           <a:p>
@@ -12920,7 +13876,7 @@
               </a:defRPr>
             </a:pPr>
             <a:r>
-              <a:t>2. Target Exposed Non-Users</a:t>
+              <a:t>Serve-Skew Prevention</a:t>
             </a:r>
           </a:p>
           <a:p>
@@ -12942,7 +13898,7 @@
               </a:defRPr>
             </a:pPr>
             <a:r>
-              <a:t>4-variable CHP filter: in a union + unemployed + Poorest quintile + arid county. Avoids wasting visits on unexposed young women.</a:t>
+              <a:t>feature_engineering.py is a shared module — identical transformations at training and serving.</a:t>
             </a:r>
           </a:p>
           <a:p>
@@ -12964,7 +13920,7 @@
               </a:defRPr>
             </a:pPr>
             <a:r>
-              <a:t>3. Employment Is the Most Actionable Lever</a:t>
+              <a:t>Model Bundle</a:t>
             </a:r>
           </a:p>
           <a:p>
@@ -12986,9 +13942,84 @@
               </a:defRPr>
             </a:pPr>
             <a:r>
-              <a:t>SHAP shows employment pushes women toward modern use. Women’s economic empowerment programs should be linked to family planning outreach.</a:t>
-            </a:r>
-          </a:p>
+              <a:t>contraceptive_model_bundle.joblib (5.6 MB): model + preprocessor + label encoder.</a:t>
+            </a:r>
+          </a:p>
+        </p:txBody>
+      </p:sp>
+      <p:sp>
+        <p:nvSpPr>
+          <p:cNvPr id="9" name="Rectangle 8"/>
+          <p:cNvSpPr/>
+          <p:nvPr/>
+        </p:nvSpPr>
+        <p:spPr>
+          <a:xfrm>
+            <a:off x="6172200" y="1508760"/>
+            <a:ext cx="5333695" cy="4663440"/>
+          </a:xfrm>
+          <a:prstGeom prst="rect">
+            <a:avLst/>
+          </a:prstGeom>
+          <a:solidFill>
+            <a:srgbClr val="FFFFFF"/>
+          </a:solidFill>
+          <a:ln w="12700">
+            <a:solidFill>
+              <a:srgbClr val="E2E8F0"/>
+            </a:solidFill>
+          </a:ln>
+          <a:effectLst>
+            <a:outerShdw blurRad="76200" dist="38100" dir="5400000" algn="tl" rotWithShape="0">
+              <a:srgbClr val="000000">
+                <a:alpha val="23000"/>
+              </a:srgbClr>
+            </a:outerShdw>
+          </a:effectLst>
+        </p:spPr>
+        <p:style>
+          <a:lnRef idx="1">
+            <a:schemeClr val="accent1"/>
+          </a:lnRef>
+          <a:fillRef idx="3">
+            <a:schemeClr val="accent1"/>
+          </a:fillRef>
+          <a:effectRef idx="2">
+            <a:schemeClr val="accent1"/>
+          </a:effectRef>
+          <a:fontRef idx="minor">
+            <a:schemeClr val="lt1"/>
+          </a:fontRef>
+        </p:style>
+        <p:txBody>
+          <a:bodyPr rtlCol="0" anchor="ctr"/>
+          <a:lstStyle/>
+          <a:p>
+            <a:pPr algn="ctr"/>
+          </a:p>
+        </p:txBody>
+      </p:sp>
+      <p:sp>
+        <p:nvSpPr>
+          <p:cNvPr id="10" name="TextBox 9"/>
+          <p:cNvSpPr txBox="1"/>
+          <p:nvPr/>
+        </p:nvSpPr>
+        <p:spPr>
+          <a:xfrm>
+            <a:off x="6355080" y="1645920"/>
+            <a:ext cx="4967935" cy="4389120"/>
+          </a:xfrm>
+          <a:prstGeom prst="rect">
+            <a:avLst/>
+          </a:prstGeom>
+          <a:noFill/>
+        </p:spPr>
+        <p:txBody>
+          <a:bodyPr wrap="square" anchor="t">
+            <a:spAutoFit/>
+          </a:bodyPr>
+          <a:lstStyle/>
           <a:p>
             <a:pPr>
               <a:lnSpc>
@@ -13008,7 +14039,7 @@
               </a:defRPr>
             </a:pPr>
             <a:r>
-              <a:t>4. Subsidize the Poorest Quintile</a:t>
+              <a:t>API Endpoints</a:t>
             </a:r>
           </a:p>
           <a:p>
@@ -13017,6 +14048,62 @@
                 <a:spcPct val="115000"/>
               </a:lnSpc>
               <a:spcBef>
+                <a:spcPts val="300"/>
+              </a:spcBef>
+              <a:spcAft>
+                <a:spcPts val="600"/>
+              </a:spcAft>
+              <a:defRPr sz="1000" b="0" i="0">
+                <a:solidFill>
+                  <a:srgbClr val="0F172A"/>
+                </a:solidFill>
+                <a:latin typeface="Consolas"/>
+              </a:defRPr>
+            </a:pPr>
+            <a:r>
+              <a:t>GET  /              HTML Form Interface</a:t>
+            </a:r>
+            <a:br/>
+            <a:r>
+              <a:t>GET  /health        Liveness Check</a:t>
+            </a:r>
+            <a:br/>
+            <a:r>
+              <a:t>POST /predict       Single Prediction</a:t>
+            </a:r>
+            <a:br/>
+            <a:r>
+              <a:t>POST /predict_batch Batch Predictions</a:t>
+            </a:r>
+          </a:p>
+          <a:p>
+            <a:pPr>
+              <a:lnSpc>
+                <a:spcPct val="110000"/>
+              </a:lnSpc>
+              <a:spcBef>
+                <a:spcPts val="800"/>
+              </a:spcBef>
+              <a:spcAft>
+                <a:spcPts val="300"/>
+              </a:spcAft>
+              <a:defRPr sz="1400" b="1" i="0">
+                <a:solidFill>
+                  <a:srgbClr val="0D9488"/>
+                </a:solidFill>
+                <a:latin typeface="Segoe UI"/>
+              </a:defRPr>
+            </a:pPr>
+            <a:r>
+              <a:t>Live URL</a:t>
+            </a:r>
+          </a:p>
+          <a:p>
+            <a:pPr>
+              <a:lnSpc>
+                <a:spcPct val="115000"/>
+              </a:lnSpc>
+              <a:spcBef>
                 <a:spcPts val="200"/>
               </a:spcBef>
               <a:spcAft>
@@ -13030,7 +14117,29 @@
               </a:defRPr>
             </a:pPr>
             <a:r>
-              <a:t>Modern use jumps 25% → 41% from Poorest to Poorer, then flattens. Target subsidies at the Poorest exclusively.</a:t>
+              <a:t>kdhs-contraceptive-api.onrender.com</a:t>
+            </a:r>
+          </a:p>
+          <a:p>
+            <a:pPr>
+              <a:lnSpc>
+                <a:spcPct val="115000"/>
+              </a:lnSpc>
+              <a:spcBef>
+                <a:spcPts val="200"/>
+              </a:spcBef>
+              <a:spcAft>
+                <a:spcPts val="400"/>
+              </a:spcAft>
+              <a:defRPr sz="1100" b="0" i="0">
+                <a:solidFill>
+                  <a:srgbClr val="334155"/>
+                </a:solidFill>
+                <a:latin typeface="Segoe UI"/>
+              </a:defRPr>
+            </a:pPr>
+            <a:r>
+              <a:t>Auth: X-API-Key header required</a:t>
             </a:r>
           </a:p>
           <a:p>
@@ -13052,7 +14161,7 @@
               </a:defRPr>
             </a:pPr>
             <a:r>
-              <a:t>5. Model Limitations</a:t>
+              <a:t>Docker Support</a:t>
             </a:r>
           </a:p>
           <a:p>
@@ -13061,20 +14170,24 @@
                 <a:spcPct val="115000"/>
               </a:lnSpc>
               <a:spcBef>
-                <a:spcPts val="200"/>
-              </a:spcBef>
-              <a:spcAft>
-                <a:spcPts val="400"/>
-              </a:spcAft>
-              <a:defRPr sz="1100" b="0" i="0">
-                <a:solidFill>
-                  <a:srgbClr val="334155"/>
-                </a:solidFill>
-                <a:latin typeface="Segoe UI"/>
-              </a:defRPr>
-            </a:pPr>
-            <a:r>
-              <a:t>Traditional/Folkloric classes too small for reliable individual prediction. Use as binary risk flag.</a:t>
+                <a:spcPts val="300"/>
+              </a:spcBef>
+              <a:spcAft>
+                <a:spcPts val="600"/>
+              </a:spcAft>
+              <a:defRPr sz="1000" b="0" i="0">
+                <a:solidFill>
+                  <a:srgbClr val="0F172A"/>
+                </a:solidFill>
+                <a:latin typeface="Consolas"/>
+              </a:defRPr>
+            </a:pPr>
+            <a:r>
+              <a:t>docker build -t kdhs-api .</a:t>
+            </a:r>
+            <a:br/>
+            <a:r>
+              <a:t>docker run -p 5000:5000 kdhs-api</a:t>
             </a:r>
           </a:p>
         </p:txBody>
@@ -13087,7 +14200,569 @@
 </p:sld>
 </file>
 
-<file path=ppt/slides/slide27.xml><?xml version="1.0" encoding="utf-8"?>
+<file path=ppt/slides/slide28.xml><?xml version="1.0" encoding="utf-8"?>
+<p:sld xmlns:a="http://schemas.openxmlformats.org/drawingml/2006/main" xmlns:p="http://schemas.openxmlformats.org/presentationml/2006/main" xmlns:r="http://schemas.openxmlformats.org/officeDocument/2006/relationships">
+  <p:cSld>
+    <p:bg>
+      <p:bgPr>
+        <a:solidFill>
+          <a:srgbClr val="F1F5F9"/>
+        </a:solidFill>
+        <a:effectLst/>
+      </p:bgPr>
+    </p:bg>
+    <p:spTree>
+      <p:nvGrpSpPr>
+        <p:cNvPr id="1" name=""/>
+        <p:cNvGrpSpPr/>
+        <p:nvPr/>
+      </p:nvGrpSpPr>
+      <p:grpSpPr/>
+      <p:sp>
+        <p:nvSpPr>
+          <p:cNvPr id="2" name="Rectangle 1"/>
+          <p:cNvSpPr/>
+          <p:nvPr/>
+        </p:nvSpPr>
+        <p:spPr>
+          <a:xfrm>
+            <a:off x="0" y="0"/>
+            <a:ext cx="12191695" cy="73152"/>
+          </a:xfrm>
+          <a:prstGeom prst="rect">
+            <a:avLst/>
+          </a:prstGeom>
+          <a:solidFill>
+            <a:srgbClr val="0D9488"/>
+          </a:solidFill>
+          <a:ln>
+            <a:noFill/>
+          </a:ln>
+        </p:spPr>
+        <p:style>
+          <a:lnRef idx="1">
+            <a:schemeClr val="accent1"/>
+          </a:lnRef>
+          <a:fillRef idx="3">
+            <a:schemeClr val="accent1"/>
+          </a:fillRef>
+          <a:effectRef idx="2">
+            <a:schemeClr val="accent1"/>
+          </a:effectRef>
+          <a:fontRef idx="minor">
+            <a:schemeClr val="lt1"/>
+          </a:fontRef>
+        </p:style>
+        <p:txBody>
+          <a:bodyPr rtlCol="0" anchor="ctr"/>
+          <a:lstStyle/>
+          <a:p>
+            <a:pPr algn="ctr"/>
+          </a:p>
+        </p:txBody>
+      </p:sp>
+      <p:sp>
+        <p:nvSpPr>
+          <p:cNvPr id="3" name="Rectangle 2"/>
+          <p:cNvSpPr/>
+          <p:nvPr/>
+        </p:nvSpPr>
+        <p:spPr>
+          <a:xfrm>
+            <a:off x="0" y="73152"/>
+            <a:ext cx="12191695" cy="27432"/>
+          </a:xfrm>
+          <a:prstGeom prst="rect">
+            <a:avLst/>
+          </a:prstGeom>
+          <a:solidFill>
+            <a:srgbClr val="D97706"/>
+          </a:solidFill>
+          <a:ln>
+            <a:noFill/>
+          </a:ln>
+        </p:spPr>
+        <p:style>
+          <a:lnRef idx="1">
+            <a:schemeClr val="accent1"/>
+          </a:lnRef>
+          <a:fillRef idx="3">
+            <a:schemeClr val="accent1"/>
+          </a:fillRef>
+          <a:effectRef idx="2">
+            <a:schemeClr val="accent1"/>
+          </a:effectRef>
+          <a:fontRef idx="minor">
+            <a:schemeClr val="lt1"/>
+          </a:fontRef>
+        </p:style>
+        <p:txBody>
+          <a:bodyPr rtlCol="0" anchor="ctr"/>
+          <a:lstStyle/>
+          <a:p>
+            <a:pPr algn="ctr"/>
+          </a:p>
+        </p:txBody>
+      </p:sp>
+      <p:sp>
+        <p:nvSpPr>
+          <p:cNvPr id="4" name="TextBox 3"/>
+          <p:cNvSpPr txBox="1"/>
+          <p:nvPr/>
+        </p:nvSpPr>
+        <p:spPr>
+          <a:xfrm>
+            <a:off x="685800" y="201168"/>
+            <a:ext cx="10515600" cy="1188720"/>
+          </a:xfrm>
+          <a:prstGeom prst="rect">
+            <a:avLst/>
+          </a:prstGeom>
+          <a:noFill/>
+        </p:spPr>
+        <p:txBody>
+          <a:bodyPr wrap="square" anchor="t">
+            <a:spAutoFit/>
+          </a:bodyPr>
+          <a:lstStyle/>
+          <a:p>
+            <a:pPr>
+              <a:lnSpc>
+                <a:spcPct val="100000"/>
+              </a:lnSpc>
+              <a:spcBef>
+                <a:spcPts val="0"/>
+              </a:spcBef>
+              <a:spcAft>
+                <a:spcPts val="200"/>
+              </a:spcAft>
+              <a:defRPr sz="900" b="1" i="0">
+                <a:solidFill>
+                  <a:srgbClr val="0D9488"/>
+                </a:solidFill>
+                <a:latin typeface="Segoe UI"/>
+              </a:defRPr>
+            </a:pPr>
+            <a:r>
+              <a:t>CAPSTONE PROJECT</a:t>
+            </a:r>
+          </a:p>
+          <a:p>
+            <a:pPr>
+              <a:lnSpc>
+                <a:spcPct val="105000"/>
+              </a:lnSpc>
+              <a:spcBef>
+                <a:spcPts val="0"/>
+              </a:spcBef>
+              <a:spcAft>
+                <a:spcPts val="0"/>
+              </a:spcAft>
+              <a:defRPr sz="2600" b="1" i="0">
+                <a:solidFill>
+                  <a:srgbClr val="0F172A"/>
+                </a:solidFill>
+                <a:latin typeface="Segoe UI"/>
+              </a:defRPr>
+            </a:pPr>
+            <a:r>
+              <a:t>Actionable Policy Recommendations</a:t>
+            </a:r>
+          </a:p>
+        </p:txBody>
+      </p:sp>
+      <p:sp>
+        <p:nvSpPr>
+          <p:cNvPr id="5" name="Rectangle 4"/>
+          <p:cNvSpPr/>
+          <p:nvPr/>
+        </p:nvSpPr>
+        <p:spPr>
+          <a:xfrm>
+            <a:off x="685800" y="6473952"/>
+            <a:ext cx="10820095" cy="13716"/>
+          </a:xfrm>
+          <a:prstGeom prst="rect">
+            <a:avLst/>
+          </a:prstGeom>
+          <a:solidFill>
+            <a:srgbClr val="E2E8F0"/>
+          </a:solidFill>
+          <a:ln>
+            <a:noFill/>
+          </a:ln>
+        </p:spPr>
+        <p:style>
+          <a:lnRef idx="1">
+            <a:schemeClr val="accent1"/>
+          </a:lnRef>
+          <a:fillRef idx="3">
+            <a:schemeClr val="accent1"/>
+          </a:fillRef>
+          <a:effectRef idx="2">
+            <a:schemeClr val="accent1"/>
+          </a:effectRef>
+          <a:fontRef idx="minor">
+            <a:schemeClr val="lt1"/>
+          </a:fontRef>
+        </p:style>
+        <p:txBody>
+          <a:bodyPr rtlCol="0" anchor="ctr"/>
+          <a:lstStyle/>
+          <a:p>
+            <a:pPr algn="ctr"/>
+          </a:p>
+        </p:txBody>
+      </p:sp>
+      <p:sp>
+        <p:nvSpPr>
+          <p:cNvPr id="6" name="TextBox 5"/>
+          <p:cNvSpPr txBox="1"/>
+          <p:nvPr/>
+        </p:nvSpPr>
+        <p:spPr>
+          <a:xfrm>
+            <a:off x="685800" y="6510528"/>
+            <a:ext cx="10817352" cy="320040"/>
+          </a:xfrm>
+          <a:prstGeom prst="rect">
+            <a:avLst/>
+          </a:prstGeom>
+          <a:noFill/>
+        </p:spPr>
+        <p:txBody>
+          <a:bodyPr wrap="square" anchor="t">
+            <a:spAutoFit/>
+          </a:bodyPr>
+          <a:lstStyle/>
+          <a:p>
+            <a:pPr>
+              <a:lnSpc>
+                <a:spcPct val="100000"/>
+              </a:lnSpc>
+              <a:spcBef>
+                <a:spcPts val="0"/>
+              </a:spcBef>
+              <a:spcAft>
+                <a:spcPts val="500"/>
+              </a:spcAft>
+              <a:defRPr sz="900" b="0" i="0">
+                <a:solidFill>
+                  <a:srgbClr val="64748B"/>
+                </a:solidFill>
+                <a:latin typeface="Segoe UI"/>
+              </a:defRPr>
+            </a:pPr>
+            <a:r>
+              <a:t>Moringa School Capstone  •  The Insight Architects  •  28 / 28</a:t>
+            </a:r>
+          </a:p>
+        </p:txBody>
+      </p:sp>
+      <p:sp>
+        <p:nvSpPr>
+          <p:cNvPr id="7" name="Rectangle 6"/>
+          <p:cNvSpPr/>
+          <p:nvPr/>
+        </p:nvSpPr>
+        <p:spPr>
+          <a:xfrm>
+            <a:off x="685800" y="1508760"/>
+            <a:ext cx="10607040" cy="4663440"/>
+          </a:xfrm>
+          <a:prstGeom prst="rect">
+            <a:avLst/>
+          </a:prstGeom>
+          <a:solidFill>
+            <a:srgbClr val="FFFFFF"/>
+          </a:solidFill>
+          <a:ln w="12700">
+            <a:solidFill>
+              <a:srgbClr val="E2E8F0"/>
+            </a:solidFill>
+          </a:ln>
+          <a:effectLst>
+            <a:outerShdw blurRad="76200" dist="38100" dir="5400000" algn="tl" rotWithShape="0">
+              <a:srgbClr val="000000">
+                <a:alpha val="23000"/>
+              </a:srgbClr>
+            </a:outerShdw>
+          </a:effectLst>
+        </p:spPr>
+        <p:style>
+          <a:lnRef idx="1">
+            <a:schemeClr val="accent1"/>
+          </a:lnRef>
+          <a:fillRef idx="3">
+            <a:schemeClr val="accent1"/>
+          </a:fillRef>
+          <a:effectRef idx="2">
+            <a:schemeClr val="accent1"/>
+          </a:effectRef>
+          <a:fontRef idx="minor">
+            <a:schemeClr val="lt1"/>
+          </a:fontRef>
+        </p:style>
+        <p:txBody>
+          <a:bodyPr rtlCol="0" anchor="ctr"/>
+          <a:lstStyle/>
+          <a:p>
+            <a:pPr algn="ctr"/>
+          </a:p>
+        </p:txBody>
+      </p:sp>
+      <p:sp>
+        <p:nvSpPr>
+          <p:cNvPr id="8" name="TextBox 7"/>
+          <p:cNvSpPr txBox="1"/>
+          <p:nvPr/>
+        </p:nvSpPr>
+        <p:spPr>
+          <a:xfrm>
+            <a:off x="868680" y="1645920"/>
+            <a:ext cx="10241280" cy="4389120"/>
+          </a:xfrm>
+          <a:prstGeom prst="rect">
+            <a:avLst/>
+          </a:prstGeom>
+          <a:noFill/>
+        </p:spPr>
+        <p:txBody>
+          <a:bodyPr wrap="square" anchor="t">
+            <a:spAutoFit/>
+          </a:bodyPr>
+          <a:lstStyle/>
+          <a:p>
+            <a:pPr>
+              <a:lnSpc>
+                <a:spcPct val="110000"/>
+              </a:lnSpc>
+              <a:spcBef>
+                <a:spcPts val="800"/>
+              </a:spcBef>
+              <a:spcAft>
+                <a:spcPts val="300"/>
+              </a:spcAft>
+              <a:defRPr sz="1400" b="1" i="0">
+                <a:solidFill>
+                  <a:srgbClr val="0D9488"/>
+                </a:solidFill>
+                <a:latin typeface="Segoe UI"/>
+              </a:defRPr>
+            </a:pPr>
+            <a:r>
+              <a:t>1. Geographic Targeting (Highest Priority)</a:t>
+            </a:r>
+          </a:p>
+          <a:p>
+            <a:pPr>
+              <a:lnSpc>
+                <a:spcPct val="115000"/>
+              </a:lnSpc>
+              <a:spcBef>
+                <a:spcPts val="200"/>
+              </a:spcBef>
+              <a:spcAft>
+                <a:spcPts val="400"/>
+              </a:spcAft>
+              <a:defRPr sz="1100" b="0" i="0">
+                <a:solidFill>
+                  <a:srgbClr val="334155"/>
+                </a:solidFill>
+                <a:latin typeface="Segoe UI"/>
+              </a:defRPr>
+            </a:pPr>
+            <a:r>
+              <a:t>Mandera (1.2%), Wajir (2.8%), Garissa (4.5%), Marsabit (5.6%), Tana River (20.0%). SHAP weight 0.096 confirms the gap persists after controlling for wealth, education, religion. Fund mobile clinics.</a:t>
+            </a:r>
+          </a:p>
+          <a:p>
+            <a:pPr>
+              <a:lnSpc>
+                <a:spcPct val="110000"/>
+              </a:lnSpc>
+              <a:spcBef>
+                <a:spcPts val="800"/>
+              </a:spcBef>
+              <a:spcAft>
+                <a:spcPts val="300"/>
+              </a:spcAft>
+              <a:defRPr sz="1400" b="1" i="0">
+                <a:solidFill>
+                  <a:srgbClr val="0D9488"/>
+                </a:solidFill>
+                <a:latin typeface="Segoe UI"/>
+              </a:defRPr>
+            </a:pPr>
+            <a:r>
+              <a:t>2. Target Exposed Non-Users, Not All Non-Users</a:t>
+            </a:r>
+          </a:p>
+          <a:p>
+            <a:pPr>
+              <a:lnSpc>
+                <a:spcPct val="115000"/>
+              </a:lnSpc>
+              <a:spcBef>
+                <a:spcPts val="200"/>
+              </a:spcBef>
+              <a:spcAft>
+                <a:spcPts val="400"/>
+              </a:spcAft>
+              <a:defRPr sz="1100" b="0" i="0">
+                <a:solidFill>
+                  <a:srgbClr val="334155"/>
+                </a:solidFill>
+                <a:latin typeface="Segoe UI"/>
+              </a:defRPr>
+            </a:pPr>
+            <a:r>
+              <a:t>4-variable CHP filter: in union + not employed + Poorest + arid county. Young never-married childless women are non-exposed, not underserved.</a:t>
+            </a:r>
+          </a:p>
+          <a:p>
+            <a:pPr>
+              <a:lnSpc>
+                <a:spcPct val="110000"/>
+              </a:lnSpc>
+              <a:spcBef>
+                <a:spcPts val="800"/>
+              </a:spcBef>
+              <a:spcAft>
+                <a:spcPts val="300"/>
+              </a:spcAft>
+              <a:defRPr sz="1400" b="1" i="0">
+                <a:solidFill>
+                  <a:srgbClr val="0D9488"/>
+                </a:solidFill>
+                <a:latin typeface="Segoe UI"/>
+              </a:defRPr>
+            </a:pPr>
+            <a:r>
+              <a:t>3. Employment-Linked Programming</a:t>
+            </a:r>
+          </a:p>
+          <a:p>
+            <a:pPr>
+              <a:lnSpc>
+                <a:spcPct val="115000"/>
+              </a:lnSpc>
+              <a:spcBef>
+                <a:spcPts val="200"/>
+              </a:spcBef>
+              <a:spcAft>
+                <a:spcPts val="400"/>
+              </a:spcAft>
+              <a:defRPr sz="1100" b="0" i="0">
+                <a:solidFill>
+                  <a:srgbClr val="334155"/>
+                </a:solidFill>
+                <a:latin typeface="Segoe UI"/>
+              </a:defRPr>
+            </a:pPr>
+            <a:r>
+              <a:t>employed is the highest-ranked policy-tractable driver. Co-locate FP info with women’s economic empowerment programmes.</a:t>
+            </a:r>
+          </a:p>
+          <a:p>
+            <a:pPr>
+              <a:lnSpc>
+                <a:spcPct val="110000"/>
+              </a:lnSpc>
+              <a:spcBef>
+                <a:spcPts val="800"/>
+              </a:spcBef>
+              <a:spcAft>
+                <a:spcPts val="300"/>
+              </a:spcAft>
+              <a:defRPr sz="1400" b="1" i="0">
+                <a:solidFill>
+                  <a:srgbClr val="0D9488"/>
+                </a:solidFill>
+                <a:latin typeface="Segoe UI"/>
+              </a:defRPr>
+            </a:pPr>
+            <a:r>
+              <a:t>4. Subsidize the Poorest Quintile</a:t>
+            </a:r>
+          </a:p>
+          <a:p>
+            <a:pPr>
+              <a:lnSpc>
+                <a:spcPct val="115000"/>
+              </a:lnSpc>
+              <a:spcBef>
+                <a:spcPts val="200"/>
+              </a:spcBef>
+              <a:spcAft>
+                <a:spcPts val="400"/>
+              </a:spcAft>
+              <a:defRPr sz="1100" b="0" i="0">
+                <a:solidFill>
+                  <a:srgbClr val="334155"/>
+                </a:solidFill>
+                <a:latin typeface="Segoe UI"/>
+              </a:defRPr>
+            </a:pPr>
+            <a:r>
+              <a:t>24.9% → 40.8% at Poorer; then only 1.8pp gain above. Target subsidies at Poorest exclusively.</a:t>
+            </a:r>
+          </a:p>
+          <a:p>
+            <a:pPr>
+              <a:lnSpc>
+                <a:spcPct val="110000"/>
+              </a:lnSpc>
+              <a:spcBef>
+                <a:spcPts val="800"/>
+              </a:spcBef>
+              <a:spcAft>
+                <a:spcPts val="300"/>
+              </a:spcAft>
+              <a:defRPr sz="1400" b="1" i="0">
+                <a:solidFill>
+                  <a:srgbClr val="0D9488"/>
+                </a:solidFill>
+                <a:latin typeface="Segoe UI"/>
+              </a:defRPr>
+            </a:pPr>
+            <a:r>
+              <a:t>5. Model Limitations (Honest)</a:t>
+            </a:r>
+          </a:p>
+          <a:p>
+            <a:pPr>
+              <a:lnSpc>
+                <a:spcPct val="115000"/>
+              </a:lnSpc>
+              <a:spcBef>
+                <a:spcPts val="200"/>
+              </a:spcBef>
+              <a:spcAft>
+                <a:spcPts val="400"/>
+              </a:spcAft>
+              <a:defRPr sz="1100" b="0" i="0">
+                <a:solidFill>
+                  <a:srgbClr val="334155"/>
+                </a:solidFill>
+                <a:latin typeface="Segoe UI"/>
+              </a:defRPr>
+            </a:pPr>
+            <a:r>
+              <a:t>Folkloric (53 cases) and Traditional cannot be predicted reliably. Use as binary Modern/Non-use risk flag, not 4-class predictor.</a:t>
+            </a:r>
+          </a:p>
+        </p:txBody>
+      </p:sp>
+    </p:spTree>
+  </p:cSld>
+  <p:clrMapOvr>
+    <a:masterClrMapping/>
+  </p:clrMapOvr>
+</p:sld>
+</file>
+
+<file path=ppt/slides/slide29.xml><?xml version="1.0" encoding="utf-8"?>
 <p:sld xmlns:a="http://schemas.openxmlformats.org/drawingml/2006/main" xmlns:p="http://schemas.openxmlformats.org/presentationml/2006/main" xmlns:r="http://schemas.openxmlformats.org/officeDocument/2006/relationships">
   <p:cSld>
     <p:bg>
@@ -13429,7 +15104,7 @@
               </a:defRPr>
             </a:pPr>
             <a:r>
-              <a:t>Moringa School Capstone  •  The Insight Architects  •  27 / 24</a:t>
+              <a:t>Moringa School Capstone  •  The Insight Architects  •  29 / 28</a:t>
             </a:r>
           </a:p>
         </p:txBody>
@@ -13696,7 +15371,7 @@
               </a:defRPr>
             </a:pPr>
             <a:r>
-              <a:t>Moringa School Capstone  •  The Insight Architects  •  3 / 24</a:t>
+              <a:t>Moringa School Capstone  •  The Insight Architects  •  3 / 28</a:t>
             </a:r>
           </a:p>
         </p:txBody>
@@ -13815,7 +15490,7 @@
               </a:defRPr>
             </a:pPr>
             <a:r>
-              <a:t>Kenya’s mCPR is ~60% nationally, hiding severe regional/socioeconomic disparities.</a:t>
+              <a:t>Kenya’s mCPR is ~57% nationally, hiding a 56-percentage-point gap between counties (Mandera 1% vs Embu 57%).</a:t>
             </a:r>
           </a:p>
           <a:p>
@@ -13837,7 +15512,7 @@
               </a:defRPr>
             </a:pPr>
             <a:r>
-              <a:t>Goal: predict modern contraceptive use to help health planners target resources.</a:t>
+              <a:t>Goal: predict contraceptive method type to help health planners target resources where non-use is highest.</a:t>
             </a:r>
           </a:p>
           <a:p>
@@ -13903,7 +15578,7 @@
               </a:defRPr>
             </a:pPr>
             <a:r>
-              <a:t>Modern method: 37.9% (12,195)</a:t>
+              <a:t>Modern: 37.9% (12,195)</a:t>
             </a:r>
           </a:p>
           <a:p>
@@ -13947,7 +15622,7 @@
               </a:defRPr>
             </a:pPr>
             <a:r>
-              <a:t>Folkloric: 0.2% (53 women)</a:t>
+              <a:t>Folkloric: 0.2% (53 women only)</a:t>
             </a:r>
           </a:p>
           <a:p>
@@ -13969,7 +15644,7 @@
               </a:defRPr>
             </a:pPr>
             <a:r>
-              <a:t>The extreme class imbalance (Folkloric has only 53 cases) is a key challenge.</a:t>
+              <a:t>The 53-row Folkloric class is the single most important structural constraint in the dataset.</a:t>
             </a:r>
           </a:p>
         </p:txBody>
@@ -14312,7 +15987,7 @@
               </a:defRPr>
             </a:pPr>
             <a:r>
-              <a:t>Moringa School Capstone  •  The Insight Architects  •  4 / 24</a:t>
+              <a:t>Moringa School Capstone  •  The Insight Architects  •  4 / 28</a:t>
             </a:r>
           </a:p>
         </p:txBody>
@@ -14431,7 +16106,7 @@
               </a:defRPr>
             </a:pPr>
             <a:r>
-              <a:t>Mean age ≈ 29.1, median 28. Numbers thin toward the 49 upper bound.</a:t>
+              <a:t>Mean age 29.1, median 28. Survey covers women aged 15–49 across all 47 counties.</a:t>
             </a:r>
           </a:p>
           <a:p>
@@ -14453,7 +16128,7 @@
               </a:defRPr>
             </a:pPr>
             <a:r>
-              <a:t>KDHS 2022 sampled women aged 15–49 across all 47 counties.</a:t>
+              <a:t>Numbers concentrate in the twenties and thin toward 49.</a:t>
             </a:r>
           </a:p>
           <a:p>
@@ -14497,7 +16172,7 @@
               </a:defRPr>
             </a:pPr>
             <a:r>
-              <a:t>Household size and living children are right-skewed.</a:t>
+              <a:t>Household size and living children are heavily right-skewed.</a:t>
             </a:r>
           </a:p>
           <a:p>
@@ -14519,7 +16194,7 @@
               </a:defRPr>
             </a:pPr>
             <a:r>
-              <a:t>print('Rows and columns:', df.shape)</a:t>
+              <a:t>print('Rows and columns:', df.shape)  # (32156, 20)</a:t>
             </a:r>
             <a:br/>
             <a:r>
@@ -14866,7 +16541,7 @@
               </a:defRPr>
             </a:pPr>
             <a:r>
-              <a:t>Moringa School Capstone  •  The Insight Architects  •  5 / 24</a:t>
+              <a:t>Moringa School Capstone  •  The Insight Architects  •  5 / 28</a:t>
             </a:r>
           </a:p>
         </p:txBody>
@@ -15073,7 +16748,7 @@
               </a:defRPr>
             </a:pPr>
             <a:r>
-              <a:t>Education influences health awareness and access to reproductive health information.</a:t>
+              <a:t>Since education influences health awareness and access to reproductive health information, this variable is expected to play an important role.</a:t>
             </a:r>
           </a:p>
         </p:txBody>
@@ -15416,7 +17091,7 @@
               </a:defRPr>
             </a:pPr>
             <a:r>
-              <a:t>Moringa School Capstone  •  The Insight Architects  •  6 / 24</a:t>
+              <a:t>Moringa School Capstone  •  The Insight Architects  •  6 / 28</a:t>
             </a:r>
           </a:p>
         </p:txBody>
@@ -15623,7 +17298,7 @@
               </a:defRPr>
             </a:pPr>
             <a:r>
-              <a:t>Urban women have marginally higher resource access; rural majority is the policy focus.</a:t>
+              <a:t>The rural majority is the primary focus for policy interventions.</a:t>
             </a:r>
           </a:p>
         </p:txBody>
@@ -15966,7 +17641,7 @@
               </a:defRPr>
             </a:pPr>
             <a:r>
-              <a:t>Moringa School Capstone  •  The Insight Architects  •  7 / 24</a:t>
+              <a:t>Moringa School Capstone  •  The Insight Architects  •  7 / 28</a:t>
             </a:r>
           </a:p>
         </p:txBody>
@@ -16085,7 +17760,7 @@
               </a:defRPr>
             </a:pPr>
             <a:r>
-              <a:t>No education: ~12% modern use vs. any education: ~37–46%.</a:t>
+              <a:t>No education: only ~12% modern use. Any education: ~37–46%.</a:t>
             </a:r>
           </a:p>
           <a:p>
@@ -16107,7 +17782,7 @@
               </a:defRPr>
             </a:pPr>
             <a:r>
-              <a:t>Primary-educated women (44%) are slightly higher than secondary (37%), likely due to age/parity confounding.</a:t>
+              <a:t>Primary-educated women (44%) are actually higher than secondary (37%) — likely a life-stage effect (secondary women average age 23.4, 55.7% never-married).</a:t>
             </a:r>
           </a:p>
           <a:p>
@@ -16494,7 +18169,7 @@
               </a:defRPr>
             </a:pPr>
             <a:r>
-              <a:t>Moringa School Capstone  •  The Insight Architects  •  8 / 24</a:t>
+              <a:t>Moringa School Capstone  •  The Insight Architects  •  8 / 28</a:t>
             </a:r>
           </a:p>
         </p:txBody>
@@ -16613,7 +18288,7 @@
               </a:defRPr>
             </a:pPr>
             <a:r>
-              <a:t>Poorest quintile: ~25% modern use. Above that, flat at ~41–43%.</a:t>
+              <a:t>Poorest quintile: ~25%. Poorer and above: flat at ~41–43%.</a:t>
             </a:r>
           </a:p>
           <a:p>
@@ -16635,7 +18310,7 @@
               </a:defRPr>
             </a:pPr>
             <a:r>
-              <a:t>The big gap is between poorest and everyone else, not a steady climb from poor to rich.</a:t>
+              <a:t>The big gap is between poorest and everyone else, not a steady climb.</a:t>
             </a:r>
           </a:p>
           <a:p>
@@ -16657,7 +18332,7 @@
               </a:defRPr>
             </a:pPr>
             <a:r>
-              <a:t>Implication</a:t>
+              <a:t>Policy Implication</a:t>
             </a:r>
           </a:p>
           <a:p>
@@ -16679,7 +18354,7 @@
               </a:defRPr>
             </a:pPr>
             <a:r>
-              <a:t>Subsidies must target the Poorest quintile exclusively for maximum ROI.</a:t>
+              <a:t>Subsidised commodities should target the Poorest quintile specifically, not spread evenly.</a:t>
             </a:r>
           </a:p>
         </p:txBody>
@@ -17022,7 +18697,7 @@
               </a:defRPr>
             </a:pPr>
             <a:r>
-              <a:t>Moringa School Capstone  •  The Insight Architects  •  9 / 24</a:t>
+              <a:t>Moringa School Capstone  •  The Insight Architects  •  9 / 28</a:t>
             </a:r>
           </a:p>
         </p:txBody>
@@ -17141,7 +18816,7 @@
               </a:defRPr>
             </a:pPr>
             <a:r>
-              <a:t>Modern use is almost identical: ~38% for both urban and rural women.</a:t>
+              <a:t>Modern use is essentially identical: ~38% for both urban and rural.</a:t>
             </a:r>
           </a:p>
           <a:p>
@@ -17185,7 +18860,7 @@
               </a:defRPr>
             </a:pPr>
             <a:r>
-              <a:t>On its own, residence barely matters. Any urban/rural gap is explained by education and wealth, not geography alone.</a:t>
+              <a:t>On its own, residence barely matters. Any urban/rural gap is explained by education and wealth, not geography.</a:t>
             </a:r>
           </a:p>
           <a:p>
@@ -17207,7 +18882,7 @@
               </a:defRPr>
             </a:pPr>
             <a:r>
-              <a:t>This means rural interventions should focus on education, not just proximity.</a:t>
+              <a:t>This means rural interventions should focus on education, not proximity.</a:t>
             </a:r>
           </a:p>
         </p:txBody>

</xml_diff>